<commit_message>
docs(testing): architektur-überblick + tool-landkarte im deck
Co-Authored-By: Claude Opus 5.5 (1M context) <noreply@anthropic.com>
Claude-Session: https://claude.ai/code/session_01PRenLBL8AH6oon1wSdsdLf
</commit_message>
<xml_diff>
--- a/docs/Frontend-Testing-Strategie für Angular.pptx
+++ b/docs/Frontend-Testing-Strategie für Angular.pptx
@@ -8,11 +8,13 @@
     <p:sldId id="256" r:id="rId2"/>
     <p:sldId id="257" r:id="rId3"/>
     <p:sldId id="258" r:id="rId4"/>
+    <p:sldId id="268" r:id="rId19"/>
     <p:sldId id="259" r:id="rId5"/>
     <p:sldId id="260" r:id="rId6"/>
     <p:sldId id="261" r:id="rId7"/>
     <p:sldId id="262" r:id="rId8"/>
     <p:sldId id="263" r:id="rId9"/>
+    <p:sldId id="269" r:id="rId20"/>
     <p:sldId id="264" r:id="rId10"/>
     <p:sldId id="265" r:id="rId11"/>
     <p:sldId id="266" r:id="rId12"/>
@@ -801,6 +803,182 @@
             <a:fld id="{F7021451-1387-4CA6-816F-3879F97B5CBC}" type="slidenum">
               <a:rPr lang="en-US"/>
               <a:t>12</a:t>
+            </a:fld>
+            <a:endParaRPr lang="en-US"/>
+          </a:p>
+        </p:txBody>
+      </p:sp>
+    </p:spTree>
+    <p:extLst>
+      <p:ext uri="{BB962C8B-B14F-4D97-AF65-F5344CB8AC3E}">
+        <p14:creationId xmlns:p14="http://schemas.microsoft.com/office/powerpoint/2010/main" val="1024086991"/>
+      </p:ext>
+    </p:extLst>
+  </p:cSld>
+  <p:clrMapOvr>
+    <a:masterClrMapping/>
+  </p:clrMapOvr>
+</p:notes>
+</file>
+
+<file path=ppt/notesSlides/notesSlide13.xml><?xml version="1.0" encoding="utf-8"?>
+<p:notes xmlns:a="http://schemas.openxmlformats.org/drawingml/2006/main" xmlns:r="http://schemas.openxmlformats.org/officeDocument/2006/relationships" xmlns:p="http://schemas.openxmlformats.org/presentationml/2006/main">
+  <p:cSld>
+    <p:spTree>
+      <p:nvGrpSpPr>
+        <p:cNvPr id="1" name=""/>
+        <p:cNvGrpSpPr/>
+        <p:nvPr/>
+      </p:nvGrpSpPr>
+      <p:grpSpPr>
+        <a:xfrm>
+          <a:off x="0" y="0"/>
+          <a:ext cx="0" cy="0"/>
+          <a:chOff x="0" y="0"/>
+          <a:chExt cx="0" cy="0"/>
+        </a:xfrm>
+      </p:grpSpPr>
+      <p:sp>
+        <p:nvSpPr>
+          <p:cNvPr id="2" name="Slide Image Placeholder 1"/>
+          <p:cNvSpPr>
+            <a:spLocks noGrp="1" noRot="1" noChangeAspect="1"/>
+          </p:cNvSpPr>
+          <p:nvPr>
+            <p:ph type="sldImg"/>
+          </p:nvPr>
+        </p:nvSpPr>
+        <p:spPr/>
+      </p:sp>
+      <p:sp>
+        <p:nvSpPr>
+          <p:cNvPr id="3" name="Notes Placeholder 2"/>
+          <p:cNvSpPr>
+            <a:spLocks noGrp="1"/>
+          </p:cNvSpPr>
+          <p:nvPr>
+            <p:ph type="body" idx="1"/>
+          </p:nvPr>
+        </p:nvSpPr>
+        <p:spPr/>
+        <p:txBody>
+          <a:bodyPr/>
+          <a:lstStyle/>
+          <a:p>
+            <a:r>
+              <a:rPr lang="en-US" dirty="0"/>
+              <a:t>Gesamtbild: Die OpenAPI-Spec ist die einzige Quelle für API-Client und Mocks. Unit läuft in Node, Component und Integration im echten Browser mit MSW als Netzwerkgrenze, E2E gegen das echte System. Die Pipeline trennt schnelles PR-Gate von E2E vor dem Release.</a:t>
+            </a:r>
+            <a:endParaRPr lang="en-US" dirty="0"/>
+          </a:p>
+        </p:txBody>
+      </p:sp>
+      <p:sp>
+        <p:nvSpPr>
+          <p:cNvPr id="4" name="Slide Number Placeholder 3"/>
+          <p:cNvSpPr>
+            <a:spLocks noGrp="1"/>
+          </p:cNvSpPr>
+          <p:nvPr>
+            <p:ph type="sldNum" sz="quarter" idx="10"/>
+          </p:nvPr>
+        </p:nvSpPr>
+        <p:spPr/>
+        <p:txBody>
+          <a:bodyPr/>
+          <a:lstStyle/>
+          <a:p>
+            <a:fld id="{F7021451-1387-4CA6-816F-3879F97B5CBC}" type="slidenum">
+              <a:rPr lang="en-US"/>
+              <a:t>9</a:t>
+            </a:fld>
+            <a:endParaRPr lang="en-US"/>
+          </a:p>
+        </p:txBody>
+      </p:sp>
+    </p:spTree>
+    <p:extLst>
+      <p:ext uri="{BB962C8B-B14F-4D97-AF65-F5344CB8AC3E}">
+        <p14:creationId xmlns:p14="http://schemas.microsoft.com/office/powerpoint/2010/main" val="1024086991"/>
+      </p:ext>
+    </p:extLst>
+  </p:cSld>
+  <p:clrMapOvr>
+    <a:masterClrMapping/>
+  </p:clrMapOvr>
+</p:notes>
+</file>
+
+<file path=ppt/notesSlides/notesSlide14.xml><?xml version="1.0" encoding="utf-8"?>
+<p:notes xmlns:a="http://schemas.openxmlformats.org/drawingml/2006/main" xmlns:r="http://schemas.openxmlformats.org/officeDocument/2006/relationships" xmlns:p="http://schemas.openxmlformats.org/presentationml/2006/main">
+  <p:cSld>
+    <p:spTree>
+      <p:nvGrpSpPr>
+        <p:cNvPr id="1" name=""/>
+        <p:cNvGrpSpPr/>
+        <p:nvPr/>
+      </p:nvGrpSpPr>
+      <p:grpSpPr>
+        <a:xfrm>
+          <a:off x="0" y="0"/>
+          <a:ext cx="0" cy="0"/>
+          <a:chOff x="0" y="0"/>
+          <a:chExt cx="0" cy="0"/>
+        </a:xfrm>
+      </p:grpSpPr>
+      <p:sp>
+        <p:nvSpPr>
+          <p:cNvPr id="2" name="Slide Image Placeholder 1"/>
+          <p:cNvSpPr>
+            <a:spLocks noGrp="1" noRot="1" noChangeAspect="1"/>
+          </p:cNvSpPr>
+          <p:nvPr>
+            <p:ph type="sldImg"/>
+          </p:nvPr>
+        </p:nvSpPr>
+        <p:spPr/>
+      </p:sp>
+      <p:sp>
+        <p:nvSpPr>
+          <p:cNvPr id="3" name="Notes Placeholder 2"/>
+          <p:cNvSpPr>
+            <a:spLocks noGrp="1"/>
+          </p:cNvSpPr>
+          <p:nvPr>
+            <p:ph type="body" idx="1"/>
+          </p:nvPr>
+        </p:nvSpPr>
+        <p:spPr/>
+        <p:txBody>
+          <a:bodyPr/>
+          <a:lstStyle/>
+          <a:p>
+            <a:r>
+              <a:rPr lang="en-US" dirty="0"/>
+              <a:t>Landkarte der Werkzeuge. Neue Werkzeuge, etwa für Accessibility oder Visual Regression, hängen sich in diese Struktur ein, statt eine neue Schicht aufzumachen.</a:t>
+            </a:r>
+            <a:endParaRPr lang="en-US" dirty="0"/>
+          </a:p>
+        </p:txBody>
+      </p:sp>
+      <p:sp>
+        <p:nvSpPr>
+          <p:cNvPr id="4" name="Slide Number Placeholder 3"/>
+          <p:cNvSpPr>
+            <a:spLocks noGrp="1"/>
+          </p:cNvSpPr>
+          <p:nvPr>
+            <p:ph type="sldNum" sz="quarter" idx="10"/>
+          </p:nvPr>
+        </p:nvSpPr>
+        <p:spPr/>
+        <p:txBody>
+          <a:bodyPr/>
+          <a:lstStyle/>
+          <a:p>
+            <a:fld id="{F7021451-1387-4CA6-816F-3879F97B5CBC}" type="slidenum">
+              <a:rPr lang="en-US"/>
+              <a:t>9</a:t>
             </a:fld>
             <a:endParaRPr lang="en-US"/>
           </a:p>
@@ -2661,7 +2839,7 @@
                 <a:ea typeface="Inter" pitchFamily="34" charset="-122"/>
                 <a:cs typeface="Inter" pitchFamily="34" charset="-120"/>
               </a:rPr>
-              <a:t>10</a:t>
+              <a:t>12</a:t>
             </a:r>
             <a:endParaRPr lang="en-US" sz="1200" dirty="0"/>
           </a:p>
@@ -3065,7 +3243,7 @@
                 <a:ea typeface="Inter" pitchFamily="34" charset="-122"/>
                 <a:cs typeface="Inter" pitchFamily="34" charset="-120"/>
               </a:rPr>
-              <a:t>11</a:t>
+              <a:t>13</a:t>
             </a:r>
             <a:endParaRPr lang="en-US" sz="1200" dirty="0"/>
           </a:p>
@@ -3341,7 +3519,2605 @@
                 <a:ea typeface="Inter" pitchFamily="34" charset="-122"/>
                 <a:cs typeface="Inter" pitchFamily="34" charset="-120"/>
               </a:rPr>
-              <a:t>12</a:t>
+              <a:t>14</a:t>
+            </a:r>
+            <a:endParaRPr lang="en-US" sz="1200" dirty="0"/>
+          </a:p>
+        </p:txBody>
+      </p:sp>
+    </p:spTree>
+  </p:cSld>
+  <p:clrMapOvr>
+    <a:masterClrMapping/>
+  </p:clrMapOvr>
+</p:sld>
+</file>
+
+<file path=ppt/slides/slide13.xml><?xml version="1.0" encoding="utf-8"?>
+<p:sld xmlns:a="http://schemas.openxmlformats.org/drawingml/2006/main" xmlns:r="http://schemas.openxmlformats.org/officeDocument/2006/relationships" xmlns:p="http://schemas.openxmlformats.org/presentationml/2006/main">
+  <p:cSld name="Slide 9">
+    <p:bg>
+      <p:bgPr>
+        <a:solidFill>
+          <a:srgbClr val="F5F3EE"/>
+        </a:solidFill>
+      </p:bgPr>
+    </p:bg>
+    <p:spTree>
+      <p:nvGrpSpPr>
+        <p:cNvPr id="1" name=""/>
+        <p:cNvGrpSpPr/>
+        <p:nvPr/>
+      </p:nvGrpSpPr>
+      <p:grpSpPr>
+        <a:xfrm>
+          <a:off x="0" y="0"/>
+          <a:ext cx="0" cy="0"/>
+          <a:chOff x="0" y="0"/>
+          <a:chExt cx="0" cy="0"/>
+        </a:xfrm>
+      </p:grpSpPr>
+      <p:sp>
+        <p:nvSpPr>
+          <p:cNvPr id="101" name="Text 101"/>
+          <p:cNvSpPr txBox="1"/>
+          <p:nvPr/>
+        </p:nvSpPr>
+        <p:spPr>
+          <a:xfrm>
+            <a:off x="812902" y="812902"/>
+            <a:ext cx="10881360" cy="475488"/>
+          </a:xfrm>
+          <a:prstGeom prst="rect">
+            <a:avLst/>
+          </a:prstGeom>
+          <a:noFill/>
+          <a:ln>
+            <a:noFill/>
+          </a:ln>
+        </p:spPr>
+        <p:txBody>
+          <a:bodyPr wrap="square" lIns="0" tIns="0" rIns="0" bIns="0" rtlCol="0" anchor="t">
+            <a:noAutofit/>
+          </a:bodyPr>
+          <a:lstStyle/>
+          <a:p>
+            <a:pPr algn="l" indent="0" marL="0">
+              <a:lnSpc>
+                <a:spcPct val="115000"/>
+              </a:lnSpc>
+              <a:buNone/>
+            </a:pPr>
+            <a:r>
+              <a:rPr lang="de-DE" sz="3200" b="1" dirty="0">
+                <a:solidFill>
+                  <a:srgbClr val="1B1E24"/>
+                </a:solidFill>
+                <a:latin typeface="Inter" pitchFamily="34" charset="0"/>
+                <a:ea typeface="Inter" pitchFamily="34" charset="-122"/>
+                <a:cs typeface="Inter" pitchFamily="34" charset="-120"/>
+              </a:rPr>
+              <a:t>Testing-Architektur im Überblick</a:t>
+            </a:r>
+            <a:endParaRPr lang="de-DE" sz="3200" dirty="0"/>
+          </a:p>
+        </p:txBody>
+      </p:sp>
+      <p:sp>
+        <p:nvSpPr>
+          <p:cNvPr id="102" name="Text 102"/>
+          <p:cNvSpPr txBox="1"/>
+          <p:nvPr/>
+        </p:nvSpPr>
+        <p:spPr>
+          <a:xfrm>
+            <a:off x="812902" y="1411834"/>
+            <a:ext cx="10881360" cy="322783"/>
+          </a:xfrm>
+          <a:prstGeom prst="rect">
+            <a:avLst/>
+          </a:prstGeom>
+          <a:noFill/>
+          <a:ln>
+            <a:noFill/>
+          </a:ln>
+        </p:spPr>
+        <p:txBody>
+          <a:bodyPr wrap="square" lIns="0" tIns="0" rIns="0" bIns="0" rtlCol="0" anchor="t">
+            <a:noAutofit/>
+          </a:bodyPr>
+          <a:lstStyle/>
+          <a:p>
+            <a:pPr algn="l" indent="0" marL="0">
+              <a:lnSpc>
+                <a:spcPct val="115000"/>
+              </a:lnSpc>
+              <a:buNone/>
+            </a:pPr>
+            <a:r>
+              <a:rPr lang="de-DE" sz="1800" dirty="0">
+                <a:solidFill>
+                  <a:srgbClr val="5D626B"/>
+                </a:solidFill>
+                <a:latin typeface="Inter" pitchFamily="34" charset="0"/>
+                <a:ea typeface="Inter" pitchFamily="34" charset="-122"/>
+                <a:cs typeface="Inter" pitchFamily="34" charset="-120"/>
+              </a:rPr>
+              <a:t>Ein Vertrag, drei Ausführungsumgebungen, zwei Gates in der Pipeline.</a:t>
+            </a:r>
+            <a:endParaRPr lang="de-DE" sz="1800" dirty="0"/>
+          </a:p>
+        </p:txBody>
+      </p:sp>
+      <p:sp>
+        <p:nvSpPr>
+          <p:cNvPr id="103" name="Text 103"/>
+          <p:cNvSpPr txBox="1"/>
+          <p:nvPr/>
+        </p:nvSpPr>
+        <p:spPr>
+          <a:xfrm>
+            <a:off x="812902" y="2011680"/>
+            <a:ext cx="1051560" cy="731520"/>
+          </a:xfrm>
+          <a:prstGeom prst="rect">
+            <a:avLst/>
+          </a:prstGeom>
+          <a:noFill/>
+          <a:ln>
+            <a:noFill/>
+          </a:ln>
+        </p:spPr>
+        <p:txBody>
+          <a:bodyPr wrap="square" lIns="0" tIns="0" rIns="0" bIns="0" rtlCol="0" anchor="ctr">
+            <a:noAutofit/>
+          </a:bodyPr>
+          <a:lstStyle/>
+          <a:p>
+            <a:pPr algn="l" indent="0" marL="0">
+              <a:lnSpc>
+                <a:spcPct val="115000"/>
+              </a:lnSpc>
+              <a:buNone/>
+            </a:pPr>
+            <a:r>
+              <a:rPr lang="de-DE" sz="1100" b="1" dirty="0">
+                <a:solidFill>
+                  <a:srgbClr val="B8461A"/>
+                </a:solidFill>
+                <a:latin typeface="Inter" pitchFamily="34" charset="0"/>
+                <a:ea typeface="Inter" pitchFamily="34" charset="-122"/>
+                <a:cs typeface="Inter" pitchFamily="34" charset="-120"/>
+              </a:rPr>
+              <a:t>VERTRAG</a:t>
+            </a:r>
+            <a:endParaRPr lang="de-DE" sz="1100" dirty="0"/>
+          </a:p>
+        </p:txBody>
+      </p:sp>
+      <p:sp>
+        <p:nvSpPr>
+          <p:cNvPr id="104" name="Text 104"/>
+          <p:cNvSpPr txBox="1"/>
+          <p:nvPr/>
+        </p:nvSpPr>
+        <p:spPr>
+          <a:xfrm>
+            <a:off x="812902" y="3063240"/>
+            <a:ext cx="1051560" cy="1828800"/>
+          </a:xfrm>
+          <a:prstGeom prst="rect">
+            <a:avLst/>
+          </a:prstGeom>
+          <a:noFill/>
+          <a:ln>
+            <a:noFill/>
+          </a:ln>
+        </p:spPr>
+        <p:txBody>
+          <a:bodyPr wrap="square" lIns="0" tIns="0" rIns="0" bIns="0" rtlCol="0" anchor="ctr">
+            <a:noAutofit/>
+          </a:bodyPr>
+          <a:lstStyle/>
+          <a:p>
+            <a:pPr algn="l" indent="0" marL="0">
+              <a:lnSpc>
+                <a:spcPct val="115000"/>
+              </a:lnSpc>
+              <a:buNone/>
+            </a:pPr>
+            <a:r>
+              <a:rPr lang="de-DE" sz="1100" b="1" dirty="0">
+                <a:solidFill>
+                  <a:srgbClr val="B8461A"/>
+                </a:solidFill>
+                <a:latin typeface="Inter" pitchFamily="34" charset="0"/>
+                <a:ea typeface="Inter" pitchFamily="34" charset="-122"/>
+                <a:cs typeface="Inter" pitchFamily="34" charset="-120"/>
+              </a:rPr>
+              <a:t>AUSFÜHRUNG</a:t>
+            </a:r>
+            <a:endParaRPr lang="de-DE" sz="1100" dirty="0"/>
+          </a:p>
+        </p:txBody>
+      </p:sp>
+      <p:sp>
+        <p:nvSpPr>
+          <p:cNvPr id="105" name="Text 105"/>
+          <p:cNvSpPr txBox="1"/>
+          <p:nvPr/>
+        </p:nvSpPr>
+        <p:spPr>
+          <a:xfrm>
+            <a:off x="812902" y="5120640"/>
+            <a:ext cx="1051560" cy="566928"/>
+          </a:xfrm>
+          <a:prstGeom prst="rect">
+            <a:avLst/>
+          </a:prstGeom>
+          <a:noFill/>
+          <a:ln>
+            <a:noFill/>
+          </a:ln>
+        </p:spPr>
+        <p:txBody>
+          <a:bodyPr wrap="square" lIns="0" tIns="0" rIns="0" bIns="0" rtlCol="0" anchor="ctr">
+            <a:noAutofit/>
+          </a:bodyPr>
+          <a:lstStyle/>
+          <a:p>
+            <a:pPr algn="l" indent="0" marL="0">
+              <a:lnSpc>
+                <a:spcPct val="115000"/>
+              </a:lnSpc>
+              <a:buNone/>
+            </a:pPr>
+            <a:r>
+              <a:rPr lang="de-DE" sz="1100" b="1" dirty="0">
+                <a:solidFill>
+                  <a:srgbClr val="B8461A"/>
+                </a:solidFill>
+                <a:latin typeface="Inter" pitchFamily="34" charset="0"/>
+                <a:ea typeface="Inter" pitchFamily="34" charset="-122"/>
+                <a:cs typeface="Inter" pitchFamily="34" charset="-120"/>
+              </a:rPr>
+              <a:t>PIPELINE</a:t>
+            </a:r>
+            <a:endParaRPr lang="de-DE" sz="1100" dirty="0"/>
+          </a:p>
+        </p:txBody>
+      </p:sp>
+      <p:sp>
+        <p:nvSpPr>
+          <p:cNvPr id="106" name="Card 106"/>
+          <p:cNvSpPr/>
+          <p:nvPr/>
+        </p:nvSpPr>
+        <p:spPr>
+          <a:xfrm>
+            <a:off x="1874520" y="2011680"/>
+            <a:ext cx="1691640" cy="731520"/>
+          </a:xfrm>
+          <a:prstGeom prst="roundRect">
+            <a:avLst>
+              <a:gd name="adj" fmla="val 8000"/>
+            </a:avLst>
+          </a:prstGeom>
+          <a:solidFill>
+            <a:srgbClr val="FDFCF9"/>
+          </a:solidFill>
+          <a:ln w="12700">
+            <a:solidFill>
+              <a:srgbClr val="E2DED4"/>
+            </a:solidFill>
+          </a:ln>
+        </p:spPr>
+        <p:txBody>
+          <a:bodyPr wrap="square" lIns="128016" tIns="128016" rIns="128016" bIns="128016" rtlCol="0" anchor="ctr">
+            <a:noAutofit/>
+          </a:bodyPr>
+          <a:lstStyle/>
+          <a:p>
+            <a:pPr algn="l" indent="0" marL="0">
+              <a:lnSpc>
+                <a:spcPct val="115000"/>
+              </a:lnSpc>
+              <a:spcAft>
+                <a:spcPts val="200"/>
+              </a:spcAft>
+              <a:buNone/>
+            </a:pPr>
+            <a:r>
+              <a:rPr lang="de-DE" sz="1400" b="1" dirty="0">
+                <a:solidFill>
+                  <a:srgbClr val="1B1E24"/>
+                </a:solidFill>
+                <a:latin typeface="Inter" pitchFamily="34" charset="0"/>
+                <a:ea typeface="Inter" pitchFamily="34" charset="-122"/>
+                <a:cs typeface="Inter" pitchFamily="34" charset="-120"/>
+              </a:rPr>
+              <a:t>OpenAPI-Spec</a:t>
+            </a:r>
+            <a:endParaRPr lang="de-DE" sz="1400" dirty="0"/>
+          </a:p>
+          <a:p>
+            <a:pPr algn="l" indent="0" marL="0">
+              <a:lnSpc>
+                <a:spcPct val="115000"/>
+              </a:lnSpc>
+              <a:buNone/>
+            </a:pPr>
+            <a:r>
+              <a:rPr lang="de-DE" sz="1100" dirty="0">
+                <a:solidFill>
+                  <a:srgbClr val="5D626B"/>
+                </a:solidFill>
+                <a:latin typeface="Inter" pitchFamily="34" charset="0"/>
+                <a:ea typeface="Inter" pitchFamily="34" charset="-122"/>
+                <a:cs typeface="Inter" pitchFamily="34" charset="-120"/>
+              </a:rPr>
+              <a:t>Backend-Vertrag</a:t>
+            </a:r>
+            <a:endParaRPr lang="de-DE" sz="1100" dirty="0"/>
+          </a:p>
+        </p:txBody>
+      </p:sp>
+      <p:cxnSp>
+        <p:nvCxnSpPr>
+          <p:cNvPr id="107" name="Arrow 107"/>
+          <p:cNvCxnSpPr/>
+          <p:nvPr/>
+        </p:nvCxnSpPr>
+        <p:spPr>
+          <a:xfrm>
+            <a:off x="3566160" y="2377440"/>
+            <a:ext cx="274320" cy="0"/>
+          </a:xfrm>
+          <a:prstGeom prst="straightConnector1">
+            <a:avLst/>
+          </a:prstGeom>
+          <a:ln w="15875">
+            <a:solidFill>
+              <a:srgbClr val="5D626B"/>
+            </a:solidFill>
+            <a:tailEnd type="triangle" w="med" len="med"/>
+          </a:ln>
+        </p:spPr>
+      </p:cxnSp>
+      <p:sp>
+        <p:nvSpPr>
+          <p:cNvPr id="108" name="Card 108"/>
+          <p:cNvSpPr/>
+          <p:nvPr/>
+        </p:nvSpPr>
+        <p:spPr>
+          <a:xfrm>
+            <a:off x="3840480" y="2011680"/>
+            <a:ext cx="2194560" cy="731520"/>
+          </a:xfrm>
+          <a:prstGeom prst="roundRect">
+            <a:avLst>
+              <a:gd name="adj" fmla="val 8000"/>
+            </a:avLst>
+          </a:prstGeom>
+          <a:solidFill>
+            <a:srgbClr val="FDFCF9"/>
+          </a:solidFill>
+          <a:ln w="12700">
+            <a:solidFill>
+              <a:srgbClr val="E2DED4"/>
+            </a:solidFill>
+          </a:ln>
+        </p:spPr>
+        <p:txBody>
+          <a:bodyPr wrap="square" lIns="128016" tIns="128016" rIns="128016" bIns="128016" rtlCol="0" anchor="ctr">
+            <a:noAutofit/>
+          </a:bodyPr>
+          <a:lstStyle/>
+          <a:p>
+            <a:pPr algn="l" indent="0" marL="0">
+              <a:lnSpc>
+                <a:spcPct val="115000"/>
+              </a:lnSpc>
+              <a:spcAft>
+                <a:spcPts val="200"/>
+              </a:spcAft>
+              <a:buNone/>
+            </a:pPr>
+            <a:r>
+              <a:rPr lang="de-DE" sz="1400" b="1" dirty="0">
+                <a:solidFill>
+                  <a:srgbClr val="1B1E24"/>
+                </a:solidFill>
+                <a:latin typeface="Inter" pitchFamily="34" charset="0"/>
+                <a:ea typeface="Inter" pitchFamily="34" charset="-122"/>
+                <a:cs typeface="Inter" pitchFamily="34" charset="-120"/>
+              </a:rPr>
+              <a:t>Codegen (Nx-Target)</a:t>
+            </a:r>
+            <a:endParaRPr lang="de-DE" sz="1400" dirty="0"/>
+          </a:p>
+          <a:p>
+            <a:pPr algn="l" indent="0" marL="0">
+              <a:lnSpc>
+                <a:spcPct val="115000"/>
+              </a:lnSpc>
+              <a:buNone/>
+            </a:pPr>
+            <a:r>
+              <a:rPr lang="de-DE" sz="1100" dirty="0">
+                <a:solidFill>
+                  <a:srgbClr val="5D626B"/>
+                </a:solidFill>
+                <a:latin typeface="Inter" pitchFamily="34" charset="0"/>
+                <a:ea typeface="Inter" pitchFamily="34" charset="-122"/>
+                <a:cs typeface="Inter" pitchFamily="34" charset="-120"/>
+              </a:rPr>
+              <a:t>generate-api-client / -testing</a:t>
+            </a:r>
+            <a:endParaRPr lang="de-DE" sz="1100" dirty="0"/>
+          </a:p>
+        </p:txBody>
+      </p:sp>
+      <p:cxnSp>
+        <p:nvCxnSpPr>
+          <p:cNvPr id="109" name="Arrow 109"/>
+          <p:cNvCxnSpPr/>
+          <p:nvPr/>
+        </p:nvCxnSpPr>
+        <p:spPr>
+          <a:xfrm>
+            <a:off x="6035040" y="2377440"/>
+            <a:ext cx="274320" cy="0"/>
+          </a:xfrm>
+          <a:prstGeom prst="straightConnector1">
+            <a:avLst/>
+          </a:prstGeom>
+          <a:ln w="15875">
+            <a:solidFill>
+              <a:srgbClr val="5D626B"/>
+            </a:solidFill>
+            <a:tailEnd type="triangle" w="med" len="med"/>
+          </a:ln>
+        </p:spPr>
+      </p:cxnSp>
+      <p:sp>
+        <p:nvSpPr>
+          <p:cNvPr id="110" name="Card 110"/>
+          <p:cNvSpPr/>
+          <p:nvPr/>
+        </p:nvSpPr>
+        <p:spPr>
+          <a:xfrm>
+            <a:off x="6309360" y="2011680"/>
+            <a:ext cx="2697480" cy="731520"/>
+          </a:xfrm>
+          <a:prstGeom prst="roundRect">
+            <a:avLst>
+              <a:gd name="adj" fmla="val 8000"/>
+            </a:avLst>
+          </a:prstGeom>
+          <a:solidFill>
+            <a:srgbClr val="FBEEE6"/>
+          </a:solidFill>
+          <a:ln w="12700">
+            <a:solidFill>
+              <a:srgbClr val="B8461A"/>
+            </a:solidFill>
+          </a:ln>
+        </p:spPr>
+        <p:txBody>
+          <a:bodyPr wrap="square" lIns="128016" tIns="128016" rIns="128016" bIns="128016" rtlCol="0" anchor="ctr">
+            <a:noAutofit/>
+          </a:bodyPr>
+          <a:lstStyle/>
+          <a:p>
+            <a:pPr algn="l" indent="0" marL="0">
+              <a:lnSpc>
+                <a:spcPct val="115000"/>
+              </a:lnSpc>
+              <a:spcAft>
+                <a:spcPts val="200"/>
+              </a:spcAft>
+              <a:buNone/>
+            </a:pPr>
+            <a:r>
+              <a:rPr lang="de-DE" sz="1400" b="1" dirty="0">
+                <a:solidFill>
+                  <a:srgbClr val="1B1E24"/>
+                </a:solidFill>
+                <a:latin typeface="Inter" pitchFamily="34" charset="0"/>
+                <a:ea typeface="Inter" pitchFamily="34" charset="-122"/>
+                <a:cs typeface="Inter" pitchFamily="34" charset="-120"/>
+              </a:rPr>
+              <a:t>API-Client &amp; Testing-Lib</a:t>
+            </a:r>
+            <a:endParaRPr lang="de-DE" sz="1400" dirty="0"/>
+          </a:p>
+          <a:p>
+            <a:pPr algn="l" indent="0" marL="0">
+              <a:lnSpc>
+                <a:spcPct val="115000"/>
+              </a:lnSpc>
+              <a:buNone/>
+            </a:pPr>
+            <a:r>
+              <a:rPr lang="de-DE" sz="1100" dirty="0">
+                <a:solidFill>
+                  <a:srgbClr val="5D626B"/>
+                </a:solidFill>
+                <a:latin typeface="Inter" pitchFamily="34" charset="0"/>
+                <a:ea typeface="Inter" pitchFamily="34" charset="-122"/>
+                <a:cs typeface="Inter" pitchFamily="34" charset="-120"/>
+              </a:rPr>
+              <a:t>Typen · MSW-Handler · Fakes</a:t>
+            </a:r>
+            <a:endParaRPr lang="de-DE" sz="1100" dirty="0"/>
+          </a:p>
+        </p:txBody>
+      </p:sp>
+      <p:sp>
+        <p:nvSpPr>
+          <p:cNvPr id="111" name="Text 111"/>
+          <p:cNvSpPr txBox="1"/>
+          <p:nvPr/>
+        </p:nvSpPr>
+        <p:spPr>
+          <a:xfrm>
+            <a:off x="9281160" y="2011680"/>
+            <a:ext cx="2097634" cy="731520"/>
+          </a:xfrm>
+          <a:prstGeom prst="rect">
+            <a:avLst/>
+          </a:prstGeom>
+          <a:noFill/>
+          <a:ln>
+            <a:noFill/>
+          </a:ln>
+        </p:spPr>
+        <p:txBody>
+          <a:bodyPr wrap="square" lIns="0" tIns="0" rIns="0" bIns="0" rtlCol="0" anchor="ctr">
+            <a:noAutofit/>
+          </a:bodyPr>
+          <a:lstStyle/>
+          <a:p>
+            <a:pPr algn="l" indent="0" marL="0">
+              <a:lnSpc>
+                <a:spcPct val="115000"/>
+              </a:lnSpc>
+              <a:buNone/>
+            </a:pPr>
+            <a:r>
+              <a:rPr lang="de-DE" sz="1100" dirty="0">
+                <a:solidFill>
+                  <a:srgbClr val="5D626B"/>
+                </a:solidFill>
+                <a:latin typeface="Inter" pitchFamily="34" charset="0"/>
+                <a:ea typeface="Inter" pitchFamily="34" charset="-122"/>
+                <a:cs typeface="Inter" pitchFamily="34" charset="-120"/>
+              </a:rPr>
+              <a:t>API-Änderung bricht den Build statt still zu driften.</a:t>
+            </a:r>
+            <a:endParaRPr lang="de-DE" sz="1100" dirty="0"/>
+          </a:p>
+        </p:txBody>
+      </p:sp>
+      <p:sp>
+        <p:nvSpPr>
+          <p:cNvPr id="112" name="Panel 112"/>
+          <p:cNvSpPr/>
+          <p:nvPr/>
+        </p:nvSpPr>
+        <p:spPr>
+          <a:xfrm>
+            <a:off x="1874520" y="3063240"/>
+            <a:ext cx="2011680" cy="1828800"/>
+          </a:xfrm>
+          <a:prstGeom prst="roundRect">
+            <a:avLst>
+              <a:gd name="adj" fmla="val 5000"/>
+            </a:avLst>
+          </a:prstGeom>
+          <a:solidFill>
+            <a:srgbClr val="FDFCF9"/>
+          </a:solidFill>
+          <a:ln w="12700">
+            <a:solidFill>
+              <a:srgbClr val="E2DED4"/>
+            </a:solidFill>
+          </a:ln>
+        </p:spPr>
+      </p:sp>
+      <p:sp>
+        <p:nvSpPr>
+          <p:cNvPr id="113" name="Text 113"/>
+          <p:cNvSpPr txBox="1"/>
+          <p:nvPr/>
+        </p:nvSpPr>
+        <p:spPr>
+          <a:xfrm>
+            <a:off x="2039112" y="3191256"/>
+            <a:ext cx="1682496" cy="274320"/>
+          </a:xfrm>
+          <a:prstGeom prst="rect">
+            <a:avLst/>
+          </a:prstGeom>
+          <a:noFill/>
+          <a:ln>
+            <a:noFill/>
+          </a:ln>
+        </p:spPr>
+        <p:txBody>
+          <a:bodyPr wrap="square" lIns="0" tIns="0" rIns="0" bIns="0" rtlCol="0" anchor="t">
+            <a:noAutofit/>
+          </a:bodyPr>
+          <a:lstStyle/>
+          <a:p>
+            <a:pPr algn="l" indent="0" marL="0">
+              <a:lnSpc>
+                <a:spcPct val="115000"/>
+              </a:lnSpc>
+              <a:buNone/>
+            </a:pPr>
+            <a:r>
+              <a:rPr lang="de-DE" sz="1500" b="1" dirty="0">
+                <a:solidFill>
+                  <a:srgbClr val="1B1E24"/>
+                </a:solidFill>
+                <a:latin typeface="Inter" pitchFamily="34" charset="0"/>
+                <a:ea typeface="Inter" pitchFamily="34" charset="-122"/>
+                <a:cs typeface="Inter" pitchFamily="34" charset="-120"/>
+              </a:rPr>
+              <a:t>Unit</a:t>
+            </a:r>
+            <a:endParaRPr lang="de-DE" sz="1500" dirty="0"/>
+          </a:p>
+        </p:txBody>
+      </p:sp>
+      <p:sp>
+        <p:nvSpPr>
+          <p:cNvPr id="114" name="Text 114"/>
+          <p:cNvSpPr txBox="1"/>
+          <p:nvPr/>
+        </p:nvSpPr>
+        <p:spPr>
+          <a:xfrm>
+            <a:off x="2039112" y="3483864"/>
+            <a:ext cx="1682496" cy="237744"/>
+          </a:xfrm>
+          <a:prstGeom prst="rect">
+            <a:avLst/>
+          </a:prstGeom>
+          <a:noFill/>
+          <a:ln>
+            <a:noFill/>
+          </a:ln>
+        </p:spPr>
+        <p:txBody>
+          <a:bodyPr wrap="square" lIns="0" tIns="0" rIns="0" bIns="0" rtlCol="0" anchor="t">
+            <a:noAutofit/>
+          </a:bodyPr>
+          <a:lstStyle/>
+          <a:p>
+            <a:pPr algn="l" indent="0" marL="0">
+              <a:lnSpc>
+                <a:spcPct val="115000"/>
+              </a:lnSpc>
+              <a:buNone/>
+            </a:pPr>
+            <a:r>
+              <a:rPr lang="de-DE" sz="1100" dirty="0">
+                <a:solidFill>
+                  <a:srgbClr val="5D626B"/>
+                </a:solidFill>
+                <a:latin typeface="Inter" pitchFamily="34" charset="0"/>
+                <a:ea typeface="Inter" pitchFamily="34" charset="-122"/>
+                <a:cs typeface="Inter" pitchFamily="34" charset="-120"/>
+              </a:rPr>
+              <a:t>Vitest · Node</a:t>
+            </a:r>
+            <a:endParaRPr lang="de-DE" sz="1100" dirty="0"/>
+          </a:p>
+        </p:txBody>
+      </p:sp>
+      <p:sp>
+        <p:nvSpPr>
+          <p:cNvPr id="115" name="Chip 115"/>
+          <p:cNvSpPr/>
+          <p:nvPr/>
+        </p:nvSpPr>
+        <p:spPr>
+          <a:xfrm>
+            <a:off x="2039112" y="3840480"/>
+            <a:ext cx="1682496" cy="274320"/>
+          </a:xfrm>
+          <a:prstGeom prst="roundRect">
+            <a:avLst>
+              <a:gd name="adj" fmla="val 15000"/>
+            </a:avLst>
+          </a:prstGeom>
+          <a:solidFill>
+            <a:srgbClr val="FFFFFF"/>
+          </a:solidFill>
+          <a:ln w="12700">
+            <a:solidFill>
+              <a:srgbClr val="E2DED4"/>
+            </a:solidFill>
+          </a:ln>
+        </p:spPr>
+        <p:txBody>
+          <a:bodyPr wrap="square" lIns="73152" tIns="73152" rIns="73152" bIns="73152" rtlCol="0" anchor="ctr">
+            <a:noAutofit/>
+          </a:bodyPr>
+          <a:lstStyle/>
+          <a:p>
+            <a:pPr algn="l" indent="0" marL="0">
+              <a:lnSpc>
+                <a:spcPct val="115000"/>
+              </a:lnSpc>
+              <a:buNone/>
+            </a:pPr>
+            <a:r>
+              <a:rPr lang="de-DE" sz="1100" dirty="0">
+                <a:solidFill>
+                  <a:srgbClr val="1B1E24"/>
+                </a:solidFill>
+                <a:latin typeface="Inter" pitchFamily="34" charset="0"/>
+                <a:ea typeface="Inter" pitchFamily="34" charset="-122"/>
+                <a:cs typeface="Inter" pitchFamily="34" charset="-120"/>
+              </a:rPr>
+              <a:t>Reine Logik</a:t>
+            </a:r>
+            <a:endParaRPr lang="de-DE" sz="1100" dirty="0"/>
+          </a:p>
+        </p:txBody>
+      </p:sp>
+      <p:sp>
+        <p:nvSpPr>
+          <p:cNvPr id="116" name="Chip 116"/>
+          <p:cNvSpPr/>
+          <p:nvPr/>
+        </p:nvSpPr>
+        <p:spPr>
+          <a:xfrm>
+            <a:off x="2039112" y="4178808"/>
+            <a:ext cx="1682496" cy="274320"/>
+          </a:xfrm>
+          <a:prstGeom prst="roundRect">
+            <a:avLst>
+              <a:gd name="adj" fmla="val 15000"/>
+            </a:avLst>
+          </a:prstGeom>
+          <a:solidFill>
+            <a:srgbClr val="FFFFFF"/>
+          </a:solidFill>
+          <a:ln w="12700">
+            <a:solidFill>
+              <a:srgbClr val="E2DED4"/>
+            </a:solidFill>
+          </a:ln>
+        </p:spPr>
+        <p:txBody>
+          <a:bodyPr wrap="square" lIns="73152" tIns="73152" rIns="73152" bIns="73152" rtlCol="0" anchor="ctr">
+            <a:noAutofit/>
+          </a:bodyPr>
+          <a:lstStyle/>
+          <a:p>
+            <a:pPr algn="l" indent="0" marL="0">
+              <a:lnSpc>
+                <a:spcPct val="115000"/>
+              </a:lnSpc>
+              <a:buNone/>
+            </a:pPr>
+            <a:r>
+              <a:rPr lang="de-DE" sz="1100" dirty="0">
+                <a:solidFill>
+                  <a:srgbClr val="1B1E24"/>
+                </a:solidFill>
+                <a:latin typeface="Inter" pitchFamily="34" charset="0"/>
+                <a:ea typeface="Inter" pitchFamily="34" charset="-122"/>
+                <a:cs typeface="Inter" pitchFamily="34" charset="-120"/>
+              </a:rPr>
+              <a:t>Utils, Pipes, Mapper</a:t>
+            </a:r>
+            <a:endParaRPr lang="de-DE" sz="1100" dirty="0"/>
+          </a:p>
+        </p:txBody>
+      </p:sp>
+      <p:sp>
+        <p:nvSpPr>
+          <p:cNvPr id="117" name="Panel 117"/>
+          <p:cNvSpPr/>
+          <p:nvPr/>
+        </p:nvSpPr>
+        <p:spPr>
+          <a:xfrm>
+            <a:off x="4160520" y="3063240"/>
+            <a:ext cx="4846320" cy="1828800"/>
+          </a:xfrm>
+          <a:prstGeom prst="roundRect">
+            <a:avLst>
+              <a:gd name="adj" fmla="val 5000"/>
+            </a:avLst>
+          </a:prstGeom>
+          <a:solidFill>
+            <a:srgbClr val="FBEEE6"/>
+          </a:solidFill>
+          <a:ln w="12700">
+            <a:solidFill>
+              <a:srgbClr val="B8461A"/>
+            </a:solidFill>
+          </a:ln>
+        </p:spPr>
+      </p:sp>
+      <p:sp>
+        <p:nvSpPr>
+          <p:cNvPr id="118" name="Text 118"/>
+          <p:cNvSpPr txBox="1"/>
+          <p:nvPr/>
+        </p:nvSpPr>
+        <p:spPr>
+          <a:xfrm>
+            <a:off x="4325112" y="3191256"/>
+            <a:ext cx="4517136" cy="274320"/>
+          </a:xfrm>
+          <a:prstGeom prst="rect">
+            <a:avLst/>
+          </a:prstGeom>
+          <a:noFill/>
+          <a:ln>
+            <a:noFill/>
+          </a:ln>
+        </p:spPr>
+        <p:txBody>
+          <a:bodyPr wrap="square" lIns="0" tIns="0" rIns="0" bIns="0" rtlCol="0" anchor="t">
+            <a:noAutofit/>
+          </a:bodyPr>
+          <a:lstStyle/>
+          <a:p>
+            <a:pPr algn="l" indent="0" marL="0">
+              <a:lnSpc>
+                <a:spcPct val="115000"/>
+              </a:lnSpc>
+              <a:buNone/>
+            </a:pPr>
+            <a:r>
+              <a:rPr lang="de-DE" sz="1500" b="1" dirty="0">
+                <a:solidFill>
+                  <a:srgbClr val="1B1E24"/>
+                </a:solidFill>
+                <a:latin typeface="Inter" pitchFamily="34" charset="0"/>
+                <a:ea typeface="Inter" pitchFamily="34" charset="-122"/>
+                <a:cs typeface="Inter" pitchFamily="34" charset="-120"/>
+              </a:rPr>
+              <a:t>Component &amp; Integration</a:t>
+            </a:r>
+            <a:endParaRPr lang="de-DE" sz="1500" dirty="0"/>
+          </a:p>
+        </p:txBody>
+      </p:sp>
+      <p:sp>
+        <p:nvSpPr>
+          <p:cNvPr id="119" name="Text 119"/>
+          <p:cNvSpPr txBox="1"/>
+          <p:nvPr/>
+        </p:nvSpPr>
+        <p:spPr>
+          <a:xfrm>
+            <a:off x="4325112" y="3483864"/>
+            <a:ext cx="4517136" cy="237744"/>
+          </a:xfrm>
+          <a:prstGeom prst="rect">
+            <a:avLst/>
+          </a:prstGeom>
+          <a:noFill/>
+          <a:ln>
+            <a:noFill/>
+          </a:ln>
+        </p:spPr>
+        <p:txBody>
+          <a:bodyPr wrap="square" lIns="0" tIns="0" rIns="0" bIns="0" rtlCol="0" anchor="t">
+            <a:noAutofit/>
+          </a:bodyPr>
+          <a:lstStyle/>
+          <a:p>
+            <a:pPr algn="l" indent="0" marL="0">
+              <a:lnSpc>
+                <a:spcPct val="115000"/>
+              </a:lnSpc>
+              <a:buNone/>
+            </a:pPr>
+            <a:r>
+              <a:rPr lang="de-DE" sz="1100" b="1" dirty="0">
+                <a:solidFill>
+                  <a:srgbClr val="B8461A"/>
+                </a:solidFill>
+                <a:latin typeface="Inter" pitchFamily="34" charset="0"/>
+                <a:ea typeface="Inter" pitchFamily="34" charset="-122"/>
+                <a:cs typeface="Inter" pitchFamily="34" charset="-120"/>
+              </a:rPr>
+              <a:t>Vitest Browser Mode · Chromium via Playwright</a:t>
+            </a:r>
+            <a:endParaRPr lang="de-DE" sz="1100" dirty="0"/>
+          </a:p>
+        </p:txBody>
+      </p:sp>
+      <p:sp>
+        <p:nvSpPr>
+          <p:cNvPr id="120" name="Chip 120"/>
+          <p:cNvSpPr/>
+          <p:nvPr/>
+        </p:nvSpPr>
+        <p:spPr>
+          <a:xfrm>
+            <a:off x="4325112" y="3840480"/>
+            <a:ext cx="4517136" cy="274320"/>
+          </a:xfrm>
+          <a:prstGeom prst="roundRect">
+            <a:avLst>
+              <a:gd name="adj" fmla="val 15000"/>
+            </a:avLst>
+          </a:prstGeom>
+          <a:solidFill>
+            <a:srgbClr val="FFFFFF"/>
+          </a:solidFill>
+          <a:ln w="12700">
+            <a:solidFill>
+              <a:srgbClr val="E2DED4"/>
+            </a:solidFill>
+          </a:ln>
+        </p:spPr>
+        <p:txBody>
+          <a:bodyPr wrap="square" lIns="73152" tIns="73152" rIns="73152" bIns="73152" rtlCol="0" anchor="ctr">
+            <a:noAutofit/>
+          </a:bodyPr>
+          <a:lstStyle/>
+          <a:p>
+            <a:pPr algn="l" indent="0" marL="0">
+              <a:lnSpc>
+                <a:spcPct val="115000"/>
+              </a:lnSpc>
+              <a:buNone/>
+            </a:pPr>
+            <a:r>
+              <a:rPr lang="de-DE" sz="1100" dirty="0">
+                <a:solidFill>
+                  <a:srgbClr val="1B1E24"/>
+                </a:solidFill>
+                <a:latin typeface="Inter" pitchFamily="34" charset="0"/>
+                <a:ea typeface="Inter" pitchFamily="34" charset="-122"/>
+                <a:cs typeface="Inter" pitchFamily="34" charset="-120"/>
+              </a:rPr>
+              <a:t>renderFeature(): echte Komponenten, Router, Stores</a:t>
+            </a:r>
+            <a:endParaRPr lang="de-DE" sz="1100" dirty="0"/>
+          </a:p>
+        </p:txBody>
+      </p:sp>
+      <p:sp>
+        <p:nvSpPr>
+          <p:cNvPr id="121" name="Chip 121"/>
+          <p:cNvSpPr/>
+          <p:nvPr/>
+        </p:nvSpPr>
+        <p:spPr>
+          <a:xfrm>
+            <a:off x="4325112" y="4178808"/>
+            <a:ext cx="4517136" cy="274320"/>
+          </a:xfrm>
+          <a:prstGeom prst="roundRect">
+            <a:avLst>
+              <a:gd name="adj" fmla="val 15000"/>
+            </a:avLst>
+          </a:prstGeom>
+          <a:solidFill>
+            <a:srgbClr val="FFFFFF"/>
+          </a:solidFill>
+          <a:ln w="12700">
+            <a:solidFill>
+              <a:srgbClr val="E2DED4"/>
+            </a:solidFill>
+          </a:ln>
+        </p:spPr>
+        <p:txBody>
+          <a:bodyPr wrap="square" lIns="73152" tIns="73152" rIns="73152" bIns="73152" rtlCol="0" anchor="ctr">
+            <a:noAutofit/>
+          </a:bodyPr>
+          <a:lstStyle/>
+          <a:p>
+            <a:pPr algn="l" indent="0" marL="0">
+              <a:lnSpc>
+                <a:spcPct val="115000"/>
+              </a:lnSpc>
+              <a:buNone/>
+            </a:pPr>
+            <a:r>
+              <a:rPr lang="de-DE" sz="1100" dirty="0">
+                <a:solidFill>
+                  <a:srgbClr val="1B1E24"/>
+                </a:solidFill>
+                <a:latin typeface="Inter" pitchFamily="34" charset="0"/>
+                <a:ea typeface="Inter" pitchFamily="34" charset="-122"/>
+                <a:cs typeface="Inter" pitchFamily="34" charset="-120"/>
+              </a:rPr>
+              <a:t>HttpClient + Interceptors echt</a:t>
+            </a:r>
+            <a:endParaRPr lang="de-DE" sz="1100" dirty="0"/>
+          </a:p>
+        </p:txBody>
+      </p:sp>
+      <p:sp>
+        <p:nvSpPr>
+          <p:cNvPr id="122" name="Chip 122"/>
+          <p:cNvSpPr/>
+          <p:nvPr/>
+        </p:nvSpPr>
+        <p:spPr>
+          <a:xfrm>
+            <a:off x="4325112" y="4517136"/>
+            <a:ext cx="4517136" cy="274320"/>
+          </a:xfrm>
+          <a:prstGeom prst="roundRect">
+            <a:avLst>
+              <a:gd name="adj" fmla="val 15000"/>
+            </a:avLst>
+          </a:prstGeom>
+          <a:solidFill>
+            <a:srgbClr val="FFFFFF"/>
+          </a:solidFill>
+          <a:ln w="12700">
+            <a:solidFill>
+              <a:srgbClr val="E2DED4"/>
+            </a:solidFill>
+          </a:ln>
+        </p:spPr>
+        <p:txBody>
+          <a:bodyPr wrap="square" lIns="73152" tIns="73152" rIns="73152" bIns="73152" rtlCol="0" anchor="ctr">
+            <a:noAutofit/>
+          </a:bodyPr>
+          <a:lstStyle/>
+          <a:p>
+            <a:pPr algn="l" indent="0" marL="0">
+              <a:lnSpc>
+                <a:spcPct val="115000"/>
+              </a:lnSpc>
+              <a:buNone/>
+            </a:pPr>
+            <a:r>
+              <a:rPr lang="de-DE" sz="1100" dirty="0">
+                <a:solidFill>
+                  <a:srgbClr val="1B1E24"/>
+                </a:solidFill>
+                <a:latin typeface="Inter" pitchFamily="34" charset="0"/>
+                <a:ea typeface="Inter" pitchFamily="34" charset="-122"/>
+                <a:cs typeface="Inter" pitchFamily="34" charset="-120"/>
+              </a:rPr>
+              <a:t>MSW Service Worker beantwortet Requests</a:t>
+            </a:r>
+            <a:endParaRPr lang="de-DE" sz="1100" dirty="0"/>
+          </a:p>
+        </p:txBody>
+      </p:sp>
+      <p:sp>
+        <p:nvSpPr>
+          <p:cNvPr id="123" name="Panel 123"/>
+          <p:cNvSpPr/>
+          <p:nvPr/>
+        </p:nvSpPr>
+        <p:spPr>
+          <a:xfrm>
+            <a:off x="9281160" y="3063240"/>
+            <a:ext cx="2097634" cy="1828800"/>
+          </a:xfrm>
+          <a:prstGeom prst="roundRect">
+            <a:avLst>
+              <a:gd name="adj" fmla="val 5000"/>
+            </a:avLst>
+          </a:prstGeom>
+          <a:solidFill>
+            <a:srgbClr val="FDFCF9"/>
+          </a:solidFill>
+          <a:ln w="12700">
+            <a:solidFill>
+              <a:srgbClr val="E2DED4"/>
+            </a:solidFill>
+          </a:ln>
+        </p:spPr>
+      </p:sp>
+      <p:sp>
+        <p:nvSpPr>
+          <p:cNvPr id="124" name="Text 124"/>
+          <p:cNvSpPr txBox="1"/>
+          <p:nvPr/>
+        </p:nvSpPr>
+        <p:spPr>
+          <a:xfrm>
+            <a:off x="9445752" y="3191256"/>
+            <a:ext cx="1768450" cy="274320"/>
+          </a:xfrm>
+          <a:prstGeom prst="rect">
+            <a:avLst/>
+          </a:prstGeom>
+          <a:noFill/>
+          <a:ln>
+            <a:noFill/>
+          </a:ln>
+        </p:spPr>
+        <p:txBody>
+          <a:bodyPr wrap="square" lIns="0" tIns="0" rIns="0" bIns="0" rtlCol="0" anchor="t">
+            <a:noAutofit/>
+          </a:bodyPr>
+          <a:lstStyle/>
+          <a:p>
+            <a:pPr algn="l" indent="0" marL="0">
+              <a:lnSpc>
+                <a:spcPct val="115000"/>
+              </a:lnSpc>
+              <a:buNone/>
+            </a:pPr>
+            <a:r>
+              <a:rPr lang="de-DE" sz="1500" b="1" dirty="0">
+                <a:solidFill>
+                  <a:srgbClr val="1B1E24"/>
+                </a:solidFill>
+                <a:latin typeface="Inter" pitchFamily="34" charset="0"/>
+                <a:ea typeface="Inter" pitchFamily="34" charset="-122"/>
+                <a:cs typeface="Inter" pitchFamily="34" charset="-120"/>
+              </a:rPr>
+              <a:t>End-to-End</a:t>
+            </a:r>
+            <a:endParaRPr lang="de-DE" sz="1500" dirty="0"/>
+          </a:p>
+        </p:txBody>
+      </p:sp>
+      <p:sp>
+        <p:nvSpPr>
+          <p:cNvPr id="125" name="Text 125"/>
+          <p:cNvSpPr txBox="1"/>
+          <p:nvPr/>
+        </p:nvSpPr>
+        <p:spPr>
+          <a:xfrm>
+            <a:off x="9445752" y="3483864"/>
+            <a:ext cx="1768450" cy="237744"/>
+          </a:xfrm>
+          <a:prstGeom prst="rect">
+            <a:avLst/>
+          </a:prstGeom>
+          <a:noFill/>
+          <a:ln>
+            <a:noFill/>
+          </a:ln>
+        </p:spPr>
+        <p:txBody>
+          <a:bodyPr wrap="square" lIns="0" tIns="0" rIns="0" bIns="0" rtlCol="0" anchor="t">
+            <a:noAutofit/>
+          </a:bodyPr>
+          <a:lstStyle/>
+          <a:p>
+            <a:pPr algn="l" indent="0" marL="0">
+              <a:lnSpc>
+                <a:spcPct val="115000"/>
+              </a:lnSpc>
+              <a:buNone/>
+            </a:pPr>
+            <a:r>
+              <a:rPr lang="de-DE" sz="1100" dirty="0">
+                <a:solidFill>
+                  <a:srgbClr val="5D626B"/>
+                </a:solidFill>
+                <a:latin typeface="Inter" pitchFamily="34" charset="0"/>
+                <a:ea typeface="Inter" pitchFamily="34" charset="-122"/>
+                <a:cs typeface="Inter" pitchFamily="34" charset="-120"/>
+              </a:rPr>
+              <a:t>Playwright</a:t>
+            </a:r>
+            <a:endParaRPr lang="de-DE" sz="1100" dirty="0"/>
+          </a:p>
+        </p:txBody>
+      </p:sp>
+      <p:sp>
+        <p:nvSpPr>
+          <p:cNvPr id="126" name="Chip 126"/>
+          <p:cNvSpPr/>
+          <p:nvPr/>
+        </p:nvSpPr>
+        <p:spPr>
+          <a:xfrm>
+            <a:off x="9445752" y="3840480"/>
+            <a:ext cx="1768450" cy="274320"/>
+          </a:xfrm>
+          <a:prstGeom prst="roundRect">
+            <a:avLst>
+              <a:gd name="adj" fmla="val 15000"/>
+            </a:avLst>
+          </a:prstGeom>
+          <a:solidFill>
+            <a:srgbClr val="FFFFFF"/>
+          </a:solidFill>
+          <a:ln w="12700">
+            <a:solidFill>
+              <a:srgbClr val="E2DED4"/>
+            </a:solidFill>
+          </a:ln>
+        </p:spPr>
+        <p:txBody>
+          <a:bodyPr wrap="square" lIns="73152" tIns="73152" rIns="73152" bIns="73152" rtlCol="0" anchor="ctr">
+            <a:noAutofit/>
+          </a:bodyPr>
+          <a:lstStyle/>
+          <a:p>
+            <a:pPr algn="l" indent="0" marL="0">
+              <a:lnSpc>
+                <a:spcPct val="115000"/>
+              </a:lnSpc>
+              <a:buNone/>
+            </a:pPr>
+            <a:r>
+              <a:rPr lang="de-DE" sz="1100" dirty="0">
+                <a:solidFill>
+                  <a:srgbClr val="1B1E24"/>
+                </a:solidFill>
+                <a:latin typeface="Inter" pitchFamily="34" charset="0"/>
+                <a:ea typeface="Inter" pitchFamily="34" charset="-122"/>
+                <a:cs typeface="Inter" pitchFamily="34" charset="-120"/>
+              </a:rPr>
+              <a:t>Deployte App</a:t>
+            </a:r>
+            <a:endParaRPr lang="de-DE" sz="1100" dirty="0"/>
+          </a:p>
+        </p:txBody>
+      </p:sp>
+      <p:sp>
+        <p:nvSpPr>
+          <p:cNvPr id="127" name="Chip 127"/>
+          <p:cNvSpPr/>
+          <p:nvPr/>
+        </p:nvSpPr>
+        <p:spPr>
+          <a:xfrm>
+            <a:off x="9445752" y="4178808"/>
+            <a:ext cx="1768450" cy="274320"/>
+          </a:xfrm>
+          <a:prstGeom prst="roundRect">
+            <a:avLst>
+              <a:gd name="adj" fmla="val 15000"/>
+            </a:avLst>
+          </a:prstGeom>
+          <a:solidFill>
+            <a:srgbClr val="FFFFFF"/>
+          </a:solidFill>
+          <a:ln w="12700">
+            <a:solidFill>
+              <a:srgbClr val="E2DED4"/>
+            </a:solidFill>
+          </a:ln>
+        </p:spPr>
+        <p:txBody>
+          <a:bodyPr wrap="square" lIns="73152" tIns="73152" rIns="73152" bIns="73152" rtlCol="0" anchor="ctr">
+            <a:noAutofit/>
+          </a:bodyPr>
+          <a:lstStyle/>
+          <a:p>
+            <a:pPr algn="l" indent="0" marL="0">
+              <a:lnSpc>
+                <a:spcPct val="115000"/>
+              </a:lnSpc>
+              <a:buNone/>
+            </a:pPr>
+            <a:r>
+              <a:rPr lang="de-DE" sz="1100" dirty="0">
+                <a:solidFill>
+                  <a:srgbClr val="1B1E24"/>
+                </a:solidFill>
+                <a:latin typeface="Inter" pitchFamily="34" charset="0"/>
+                <a:ea typeface="Inter" pitchFamily="34" charset="-122"/>
+                <a:cs typeface="Inter" pitchFamily="34" charset="-120"/>
+              </a:rPr>
+              <a:t>Echtes Backend</a:t>
+            </a:r>
+            <a:endParaRPr lang="de-DE" sz="1100" dirty="0"/>
+          </a:p>
+        </p:txBody>
+      </p:sp>
+      <p:cxnSp>
+        <p:nvCxnSpPr>
+          <p:cNvPr id="128" name="Arrow 128"/>
+          <p:cNvCxnSpPr/>
+          <p:nvPr/>
+        </p:nvCxnSpPr>
+        <p:spPr>
+          <a:xfrm>
+            <a:off x="7658100" y="2743200"/>
+            <a:ext cx="0" cy="320040"/>
+          </a:xfrm>
+          <a:prstGeom prst="straightConnector1">
+            <a:avLst/>
+          </a:prstGeom>
+          <a:ln w="15875">
+            <a:solidFill>
+              <a:srgbClr val="B8461A"/>
+            </a:solidFill>
+            <a:prstDash val="dash"/>
+            <a:tailEnd type="triangle" w="med" len="med"/>
+          </a:ln>
+        </p:spPr>
+      </p:cxnSp>
+      <p:sp>
+        <p:nvSpPr>
+          <p:cNvPr id="129" name="Text 129"/>
+          <p:cNvSpPr txBox="1"/>
+          <p:nvPr/>
+        </p:nvSpPr>
+        <p:spPr>
+          <a:xfrm>
+            <a:off x="7726680" y="2761488"/>
+            <a:ext cx="1280160" cy="274320"/>
+          </a:xfrm>
+          <a:prstGeom prst="rect">
+            <a:avLst/>
+          </a:prstGeom>
+          <a:noFill/>
+          <a:ln>
+            <a:noFill/>
+          </a:ln>
+        </p:spPr>
+        <p:txBody>
+          <a:bodyPr wrap="square" lIns="0" tIns="0" rIns="0" bIns="0" rtlCol="0" anchor="ctr">
+            <a:noAutofit/>
+          </a:bodyPr>
+          <a:lstStyle/>
+          <a:p>
+            <a:pPr algn="l" indent="0" marL="0">
+              <a:lnSpc>
+                <a:spcPct val="115000"/>
+              </a:lnSpc>
+              <a:buNone/>
+            </a:pPr>
+            <a:r>
+              <a:rPr lang="de-DE" sz="1000" b="1" dirty="0">
+                <a:solidFill>
+                  <a:srgbClr val="B8461A"/>
+                </a:solidFill>
+                <a:latin typeface="Inter" pitchFamily="34" charset="0"/>
+                <a:ea typeface="Inter" pitchFamily="34" charset="-122"/>
+                <a:cs typeface="Inter" pitchFamily="34" charset="-120"/>
+              </a:rPr>
+              <a:t>Handler</a:t>
+            </a:r>
+            <a:endParaRPr lang="de-DE" sz="1000" dirty="0"/>
+          </a:p>
+        </p:txBody>
+      </p:sp>
+      <p:sp>
+        <p:nvSpPr>
+          <p:cNvPr id="130" name="Card 130"/>
+          <p:cNvSpPr/>
+          <p:nvPr/>
+        </p:nvSpPr>
+        <p:spPr>
+          <a:xfrm>
+            <a:off x="1874520" y="5120640"/>
+            <a:ext cx="7132320" cy="566928"/>
+          </a:xfrm>
+          <a:prstGeom prst="roundRect">
+            <a:avLst>
+              <a:gd name="adj" fmla="val 8000"/>
+            </a:avLst>
+          </a:prstGeom>
+          <a:solidFill>
+            <a:srgbClr val="FDFCF9"/>
+          </a:solidFill>
+          <a:ln w="12700">
+            <a:solidFill>
+              <a:srgbClr val="E2DED4"/>
+            </a:solidFill>
+          </a:ln>
+        </p:spPr>
+        <p:txBody>
+          <a:bodyPr wrap="square" lIns="128016" tIns="128016" rIns="128016" bIns="128016" rtlCol="0" anchor="ctr">
+            <a:noAutofit/>
+          </a:bodyPr>
+          <a:lstStyle/>
+          <a:p>
+            <a:pPr algn="l" indent="0" marL="0">
+              <a:lnSpc>
+                <a:spcPct val="115000"/>
+              </a:lnSpc>
+              <a:spcAft>
+                <a:spcPts val="200"/>
+              </a:spcAft>
+              <a:buNone/>
+            </a:pPr>
+            <a:r>
+              <a:rPr lang="de-DE" sz="1400" b="1" dirty="0">
+                <a:solidFill>
+                  <a:srgbClr val="1B1E24"/>
+                </a:solidFill>
+                <a:latin typeface="Inter" pitchFamily="34" charset="0"/>
+                <a:ea typeface="Inter" pitchFamily="34" charset="-122"/>
+                <a:cs typeface="Inter" pitchFamily="34" charset="-120"/>
+              </a:rPr>
+              <a:t>PR-Gate · nx affected</a:t>
+            </a:r>
+            <a:endParaRPr lang="de-DE" sz="1400" dirty="0"/>
+          </a:p>
+          <a:p>
+            <a:pPr algn="l" indent="0" marL="0">
+              <a:lnSpc>
+                <a:spcPct val="115000"/>
+              </a:lnSpc>
+              <a:buNone/>
+            </a:pPr>
+            <a:r>
+              <a:rPr lang="de-DE" sz="1100" dirty="0">
+                <a:solidFill>
+                  <a:srgbClr val="5D626B"/>
+                </a:solidFill>
+                <a:latin typeface="Inter" pitchFamily="34" charset="0"/>
+                <a:ea typeface="Inter" pitchFamily="34" charset="-122"/>
+                <a:cs typeface="Inter" pitchFamily="34" charset="-120"/>
+              </a:rPr>
+              <a:t>Unit, Component und Integration blockieren den Merge · Coverage (v8) nur als Indikator</a:t>
+            </a:r>
+            <a:endParaRPr lang="de-DE" sz="1100" dirty="0"/>
+          </a:p>
+        </p:txBody>
+      </p:sp>
+      <p:sp>
+        <p:nvSpPr>
+          <p:cNvPr id="131" name="Card 131"/>
+          <p:cNvSpPr/>
+          <p:nvPr/>
+        </p:nvSpPr>
+        <p:spPr>
+          <a:xfrm>
+            <a:off x="9281160" y="5120640"/>
+            <a:ext cx="2097634" cy="566928"/>
+          </a:xfrm>
+          <a:prstGeom prst="roundRect">
+            <a:avLst>
+              <a:gd name="adj" fmla="val 8000"/>
+            </a:avLst>
+          </a:prstGeom>
+          <a:solidFill>
+            <a:srgbClr val="FDFCF9"/>
+          </a:solidFill>
+          <a:ln w="12700">
+            <a:solidFill>
+              <a:srgbClr val="E2DED4"/>
+            </a:solidFill>
+          </a:ln>
+        </p:spPr>
+        <p:txBody>
+          <a:bodyPr wrap="square" lIns="128016" tIns="128016" rIns="128016" bIns="128016" rtlCol="0" anchor="ctr">
+            <a:noAutofit/>
+          </a:bodyPr>
+          <a:lstStyle/>
+          <a:p>
+            <a:pPr algn="l" indent="0" marL="0">
+              <a:lnSpc>
+                <a:spcPct val="115000"/>
+              </a:lnSpc>
+              <a:spcAft>
+                <a:spcPts val="200"/>
+              </a:spcAft>
+              <a:buNone/>
+            </a:pPr>
+            <a:r>
+              <a:rPr lang="de-DE" sz="1400" b="1" dirty="0">
+                <a:solidFill>
+                  <a:srgbClr val="1B1E24"/>
+                </a:solidFill>
+                <a:latin typeface="Inter" pitchFamily="34" charset="0"/>
+                <a:ea typeface="Inter" pitchFamily="34" charset="-122"/>
+                <a:cs typeface="Inter" pitchFamily="34" charset="-120"/>
+              </a:rPr>
+              <a:t>Release-Gate</a:t>
+            </a:r>
+            <a:endParaRPr lang="de-DE" sz="1400" dirty="0"/>
+          </a:p>
+          <a:p>
+            <a:pPr algn="l" indent="0" marL="0">
+              <a:lnSpc>
+                <a:spcPct val="115000"/>
+              </a:lnSpc>
+              <a:buNone/>
+            </a:pPr>
+            <a:r>
+              <a:rPr lang="de-DE" sz="1100" dirty="0">
+                <a:solidFill>
+                  <a:srgbClr val="5D626B"/>
+                </a:solidFill>
+                <a:latin typeface="Inter" pitchFamily="34" charset="0"/>
+                <a:ea typeface="Inter" pitchFamily="34" charset="-122"/>
+                <a:cs typeface="Inter" pitchFamily="34" charset="-120"/>
+              </a:rPr>
+              <a:t>E2E vor jedem Release</a:t>
+            </a:r>
+            <a:endParaRPr lang="de-DE" sz="1100" dirty="0"/>
+          </a:p>
+        </p:txBody>
+      </p:sp>
+      <p:sp>
+        <p:nvSpPr>
+          <p:cNvPr id="13" name="Text 11"/>
+          <p:cNvSpPr/>
+          <p:nvPr/>
+        </p:nvSpPr>
+        <p:spPr>
+          <a:xfrm>
+            <a:off x="812800" y="6238280"/>
+            <a:ext cx="2876389" cy="238720"/>
+          </a:xfrm>
+          <a:prstGeom prst="rect">
+            <a:avLst/>
+          </a:prstGeom>
+          <a:noFill/>
+          <a:ln/>
+        </p:spPr>
+        <p:txBody>
+          <a:bodyPr wrap="square" lIns="0" tIns="0" rIns="0" bIns="0" rtlCol="0" anchor="t">
+            <a:normAutofit/>
+          </a:bodyPr>
+          <a:lstStyle/>
+          <a:p>
+            <a:pPr algn="l" indent="0" marL="0">
+              <a:lnSpc>
+                <a:spcPts val="1680"/>
+              </a:lnSpc>
+              <a:buNone/>
+            </a:pPr>
+            <a:r>
+              <a:rPr lang="en-US" sz="1200" dirty="0">
+                <a:solidFill>
+                  <a:srgbClr val="5D626B"/>
+                </a:solidFill>
+                <a:latin typeface="Inter" pitchFamily="34" charset="0"/>
+                <a:ea typeface="Inter" pitchFamily="34" charset="-122"/>
+                <a:cs typeface="Inter" pitchFamily="34" charset="-120"/>
+              </a:rPr>
+              <a:t>Frontend-Testing-Strategie für Angular</a:t>
+            </a:r>
+            <a:endParaRPr lang="en-US" sz="1200" dirty="0"/>
+          </a:p>
+        </p:txBody>
+      </p:sp>
+      <p:sp>
+        <p:nvSpPr>
+          <p:cNvPr id="14" name="Text 12"/>
+          <p:cNvSpPr/>
+          <p:nvPr/>
+        </p:nvSpPr>
+        <p:spPr>
+          <a:xfrm>
+            <a:off x="11188502" y="6238280"/>
+            <a:ext cx="241498" cy="238720"/>
+          </a:xfrm>
+          <a:prstGeom prst="rect">
+            <a:avLst/>
+          </a:prstGeom>
+          <a:noFill/>
+          <a:ln/>
+        </p:spPr>
+        <p:txBody>
+          <a:bodyPr wrap="square" lIns="0" tIns="0" rIns="0" bIns="0" rtlCol="0" anchor="t">
+            <a:normAutofit/>
+          </a:bodyPr>
+          <a:lstStyle/>
+          <a:p>
+            <a:pPr algn="l" indent="0" marL="0">
+              <a:lnSpc>
+                <a:spcPts val="1680"/>
+              </a:lnSpc>
+              <a:buNone/>
+            </a:pPr>
+            <a:r>
+              <a:rPr lang="en-US" sz="1200" dirty="0">
+                <a:solidFill>
+                  <a:srgbClr val="5D626B"/>
+                </a:solidFill>
+                <a:latin typeface="Inter" pitchFamily="34" charset="0"/>
+                <a:ea typeface="Inter" pitchFamily="34" charset="-122"/>
+                <a:cs typeface="Inter" pitchFamily="34" charset="-120"/>
+              </a:rPr>
+              <a:t>04</a:t>
+            </a:r>
+            <a:endParaRPr lang="en-US" sz="1200" dirty="0"/>
+          </a:p>
+        </p:txBody>
+      </p:sp>
+    </p:spTree>
+  </p:cSld>
+  <p:clrMapOvr>
+    <a:masterClrMapping/>
+  </p:clrMapOvr>
+</p:sld>
+</file>
+
+<file path=ppt/slides/slide14.xml><?xml version="1.0" encoding="utf-8"?>
+<p:sld xmlns:a="http://schemas.openxmlformats.org/drawingml/2006/main" xmlns:r="http://schemas.openxmlformats.org/officeDocument/2006/relationships" xmlns:p="http://schemas.openxmlformats.org/presentationml/2006/main">
+  <p:cSld name="Slide 9">
+    <p:bg>
+      <p:bgPr>
+        <a:solidFill>
+          <a:srgbClr val="F5F3EE"/>
+        </a:solidFill>
+      </p:bgPr>
+    </p:bg>
+    <p:spTree>
+      <p:nvGrpSpPr>
+        <p:cNvPr id="1" name=""/>
+        <p:cNvGrpSpPr/>
+        <p:nvPr/>
+      </p:nvGrpSpPr>
+      <p:grpSpPr>
+        <a:xfrm>
+          <a:off x="0" y="0"/>
+          <a:ext cx="0" cy="0"/>
+          <a:chOff x="0" y="0"/>
+          <a:chExt cx="0" cy="0"/>
+        </a:xfrm>
+      </p:grpSpPr>
+      <p:sp>
+        <p:nvSpPr>
+          <p:cNvPr id="132" name="Text 132"/>
+          <p:cNvSpPr txBox="1"/>
+          <p:nvPr/>
+        </p:nvSpPr>
+        <p:spPr>
+          <a:xfrm>
+            <a:off x="812902" y="812902"/>
+            <a:ext cx="10881360" cy="475488"/>
+          </a:xfrm>
+          <a:prstGeom prst="rect">
+            <a:avLst/>
+          </a:prstGeom>
+          <a:noFill/>
+          <a:ln>
+            <a:noFill/>
+          </a:ln>
+        </p:spPr>
+        <p:txBody>
+          <a:bodyPr wrap="square" lIns="0" tIns="0" rIns="0" bIns="0" rtlCol="0" anchor="t">
+            <a:noAutofit/>
+          </a:bodyPr>
+          <a:lstStyle/>
+          <a:p>
+            <a:pPr algn="l" indent="0" marL="0">
+              <a:lnSpc>
+                <a:spcPct val="115000"/>
+              </a:lnSpc>
+              <a:buNone/>
+            </a:pPr>
+            <a:r>
+              <a:rPr lang="de-DE" sz="3200" b="1" dirty="0">
+                <a:solidFill>
+                  <a:srgbClr val="1B1E24"/>
+                </a:solidFill>
+                <a:latin typeface="Inter" pitchFamily="34" charset="0"/>
+                <a:ea typeface="Inter" pitchFamily="34" charset="-122"/>
+                <a:cs typeface="Inter" pitchFamily="34" charset="-120"/>
+              </a:rPr>
+              <a:t>Werkzeuge und ihre Rolle</a:t>
+            </a:r>
+            <a:endParaRPr lang="de-DE" sz="3200" dirty="0"/>
+          </a:p>
+        </p:txBody>
+      </p:sp>
+      <p:sp>
+        <p:nvSpPr>
+          <p:cNvPr id="133" name="Text 133"/>
+          <p:cNvSpPr txBox="1"/>
+          <p:nvPr/>
+        </p:nvSpPr>
+        <p:spPr>
+          <a:xfrm>
+            <a:off x="812902" y="1411834"/>
+            <a:ext cx="10881360" cy="322783"/>
+          </a:xfrm>
+          <a:prstGeom prst="rect">
+            <a:avLst/>
+          </a:prstGeom>
+          <a:noFill/>
+          <a:ln>
+            <a:noFill/>
+          </a:ln>
+        </p:spPr>
+        <p:txBody>
+          <a:bodyPr wrap="square" lIns="0" tIns="0" rIns="0" bIns="0" rtlCol="0" anchor="t">
+            <a:noAutofit/>
+          </a:bodyPr>
+          <a:lstStyle/>
+          <a:p>
+            <a:pPr algn="l" indent="0" marL="0">
+              <a:lnSpc>
+                <a:spcPct val="115000"/>
+              </a:lnSpc>
+              <a:buNone/>
+            </a:pPr>
+            <a:r>
+              <a:rPr lang="de-DE" sz="1800" dirty="0">
+                <a:solidFill>
+                  <a:srgbClr val="5D626B"/>
+                </a:solidFill>
+                <a:latin typeface="Inter" pitchFamily="34" charset="0"/>
+                <a:ea typeface="Inter" pitchFamily="34" charset="-122"/>
+                <a:cs typeface="Inter" pitchFamily="34" charset="-120"/>
+              </a:rPr>
+              <a:t>Jedes Werkzeug hat genau eine Aufgabe – zusammen bilden sie die Architektur.</a:t>
+            </a:r>
+            <a:endParaRPr lang="de-DE" sz="1800" dirty="0"/>
+          </a:p>
+        </p:txBody>
+      </p:sp>
+      <p:sp>
+        <p:nvSpPr>
+          <p:cNvPr id="134" name="Tool 134"/>
+          <p:cNvSpPr/>
+          <p:nvPr/>
+        </p:nvSpPr>
+        <p:spPr>
+          <a:xfrm>
+            <a:off x="812902" y="2103120"/>
+            <a:ext cx="2470023" cy="1508760"/>
+          </a:xfrm>
+          <a:prstGeom prst="roundRect">
+            <a:avLst>
+              <a:gd name="adj" fmla="val 6000"/>
+            </a:avLst>
+          </a:prstGeom>
+          <a:solidFill>
+            <a:srgbClr val="FDFCF9"/>
+          </a:solidFill>
+          <a:ln w="12700">
+            <a:solidFill>
+              <a:srgbClr val="E2DED4"/>
+            </a:solidFill>
+          </a:ln>
+        </p:spPr>
+        <p:txBody>
+          <a:bodyPr wrap="square" lIns="182880" tIns="182880" rIns="182880" bIns="182880" rtlCol="0" anchor="t">
+            <a:noAutofit/>
+          </a:bodyPr>
+          <a:lstStyle/>
+          <a:p>
+            <a:pPr algn="l" indent="0" marL="0">
+              <a:lnSpc>
+                <a:spcPct val="115000"/>
+              </a:lnSpc>
+              <a:spcAft>
+                <a:spcPts val="600"/>
+              </a:spcAft>
+              <a:buNone/>
+            </a:pPr>
+            <a:r>
+              <a:rPr lang="de-DE" sz="1700" b="1" dirty="0">
+                <a:solidFill>
+                  <a:srgbClr val="1B1E24"/>
+                </a:solidFill>
+                <a:latin typeface="Inter" pitchFamily="34" charset="0"/>
+                <a:ea typeface="Inter" pitchFamily="34" charset="-122"/>
+                <a:cs typeface="Inter" pitchFamily="34" charset="-120"/>
+              </a:rPr>
+              <a:t>Vitest</a:t>
+            </a:r>
+            <a:endParaRPr lang="de-DE" sz="1700" dirty="0"/>
+          </a:p>
+          <a:p>
+            <a:pPr algn="l" indent="0" marL="0">
+              <a:lnSpc>
+                <a:spcPct val="115000"/>
+              </a:lnSpc>
+              <a:spcAft>
+                <a:spcPts val="800"/>
+              </a:spcAft>
+              <a:buNone/>
+            </a:pPr>
+            <a:r>
+              <a:rPr lang="de-DE" sz="1200" dirty="0">
+                <a:solidFill>
+                  <a:srgbClr val="5D626B"/>
+                </a:solidFill>
+                <a:latin typeface="Inter" pitchFamily="34" charset="0"/>
+                <a:ea typeface="Inter" pitchFamily="34" charset="-122"/>
+                <a:cs typeface="Inter" pitchFamily="34" charset="-120"/>
+              </a:rPr>
+              <a:t>Runner für Unit-, Component- und Integrationstests</a:t>
+            </a:r>
+            <a:endParaRPr lang="de-DE" sz="1200" dirty="0"/>
+          </a:p>
+          <a:p>
+            <a:pPr algn="l" indent="0" marL="0">
+              <a:lnSpc>
+                <a:spcPct val="115000"/>
+              </a:lnSpc>
+              <a:buNone/>
+            </a:pPr>
+            <a:r>
+              <a:rPr lang="de-DE" sz="1100" b="1" dirty="0">
+                <a:solidFill>
+                  <a:srgbClr val="B8461A"/>
+                </a:solidFill>
+                <a:latin typeface="Inter" pitchFamily="34" charset="0"/>
+                <a:ea typeface="Inter" pitchFamily="34" charset="-122"/>
+                <a:cs typeface="Inter" pitchFamily="34" charset="-120"/>
+              </a:rPr>
+              <a:t>Unit · Component · Integration</a:t>
+            </a:r>
+            <a:endParaRPr lang="de-DE" sz="1100" dirty="0"/>
+          </a:p>
+        </p:txBody>
+      </p:sp>
+      <p:sp>
+        <p:nvSpPr>
+          <p:cNvPr id="135" name="Tool 135"/>
+          <p:cNvSpPr/>
+          <p:nvPr/>
+        </p:nvSpPr>
+        <p:spPr>
+          <a:xfrm>
+            <a:off x="3511525" y="2103120"/>
+            <a:ext cx="2470023" cy="1508760"/>
+          </a:xfrm>
+          <a:prstGeom prst="roundRect">
+            <a:avLst>
+              <a:gd name="adj" fmla="val 6000"/>
+            </a:avLst>
+          </a:prstGeom>
+          <a:solidFill>
+            <a:srgbClr val="FDFCF9"/>
+          </a:solidFill>
+          <a:ln w="12700">
+            <a:solidFill>
+              <a:srgbClr val="E2DED4"/>
+            </a:solidFill>
+          </a:ln>
+        </p:spPr>
+        <p:txBody>
+          <a:bodyPr wrap="square" lIns="182880" tIns="182880" rIns="182880" bIns="182880" rtlCol="0" anchor="t">
+            <a:noAutofit/>
+          </a:bodyPr>
+          <a:lstStyle/>
+          <a:p>
+            <a:pPr algn="l" indent="0" marL="0">
+              <a:lnSpc>
+                <a:spcPct val="115000"/>
+              </a:lnSpc>
+              <a:spcAft>
+                <a:spcPts val="600"/>
+              </a:spcAft>
+              <a:buNone/>
+            </a:pPr>
+            <a:r>
+              <a:rPr lang="de-DE" sz="1700" b="1" dirty="0">
+                <a:solidFill>
+                  <a:srgbClr val="1B1E24"/>
+                </a:solidFill>
+                <a:latin typeface="Inter" pitchFamily="34" charset="0"/>
+                <a:ea typeface="Inter" pitchFamily="34" charset="-122"/>
+                <a:cs typeface="Inter" pitchFamily="34" charset="-120"/>
+              </a:rPr>
+              <a:t>Vitest Browser Mode</a:t>
+            </a:r>
+            <a:endParaRPr lang="de-DE" sz="1700" dirty="0"/>
+          </a:p>
+          <a:p>
+            <a:pPr algn="l" indent="0" marL="0">
+              <a:lnSpc>
+                <a:spcPct val="115000"/>
+              </a:lnSpc>
+              <a:spcAft>
+                <a:spcPts val="800"/>
+              </a:spcAft>
+              <a:buNone/>
+            </a:pPr>
+            <a:r>
+              <a:rPr lang="de-DE" sz="1200" dirty="0">
+                <a:solidFill>
+                  <a:srgbClr val="5D626B"/>
+                </a:solidFill>
+                <a:latin typeface="Inter" pitchFamily="34" charset="0"/>
+                <a:ea typeface="Inter" pitchFamily="34" charset="-122"/>
+                <a:cs typeface="Inter" pitchFamily="34" charset="-120"/>
+              </a:rPr>
+              <a:t>Tests laufen in echtem Chromium, Provider Playwright</a:t>
+            </a:r>
+            <a:endParaRPr lang="de-DE" sz="1200" dirty="0"/>
+          </a:p>
+          <a:p>
+            <a:pPr algn="l" indent="0" marL="0">
+              <a:lnSpc>
+                <a:spcPct val="115000"/>
+              </a:lnSpc>
+              <a:buNone/>
+            </a:pPr>
+            <a:r>
+              <a:rPr lang="de-DE" sz="1100" b="1" dirty="0">
+                <a:solidFill>
+                  <a:srgbClr val="B8461A"/>
+                </a:solidFill>
+                <a:latin typeface="Inter" pitchFamily="34" charset="0"/>
+                <a:ea typeface="Inter" pitchFamily="34" charset="-122"/>
+                <a:cs typeface="Inter" pitchFamily="34" charset="-120"/>
+              </a:rPr>
+              <a:t>Component · Integration</a:t>
+            </a:r>
+            <a:endParaRPr lang="de-DE" sz="1100" dirty="0"/>
+          </a:p>
+        </p:txBody>
+      </p:sp>
+      <p:sp>
+        <p:nvSpPr>
+          <p:cNvPr id="136" name="Tool 136"/>
+          <p:cNvSpPr/>
+          <p:nvPr/>
+        </p:nvSpPr>
+        <p:spPr>
+          <a:xfrm>
+            <a:off x="6210148" y="2103120"/>
+            <a:ext cx="2470023" cy="1508760"/>
+          </a:xfrm>
+          <a:prstGeom prst="roundRect">
+            <a:avLst>
+              <a:gd name="adj" fmla="val 6000"/>
+            </a:avLst>
+          </a:prstGeom>
+          <a:solidFill>
+            <a:srgbClr val="FDFCF9"/>
+          </a:solidFill>
+          <a:ln w="12700">
+            <a:solidFill>
+              <a:srgbClr val="E2DED4"/>
+            </a:solidFill>
+          </a:ln>
+        </p:spPr>
+        <p:txBody>
+          <a:bodyPr wrap="square" lIns="182880" tIns="182880" rIns="182880" bIns="182880" rtlCol="0" anchor="t">
+            <a:noAutofit/>
+          </a:bodyPr>
+          <a:lstStyle/>
+          <a:p>
+            <a:pPr algn="l" indent="0" marL="0">
+              <a:lnSpc>
+                <a:spcPct val="115000"/>
+              </a:lnSpc>
+              <a:spcAft>
+                <a:spcPts val="600"/>
+              </a:spcAft>
+              <a:buNone/>
+            </a:pPr>
+            <a:r>
+              <a:rPr lang="de-DE" sz="1700" b="1" dirty="0">
+                <a:solidFill>
+                  <a:srgbClr val="1B1E24"/>
+                </a:solidFill>
+                <a:latin typeface="Inter" pitchFamily="34" charset="0"/>
+                <a:ea typeface="Inter" pitchFamily="34" charset="-122"/>
+                <a:cs typeface="Inter" pitchFamily="34" charset="-120"/>
+              </a:rPr>
+              <a:t>Playwright</a:t>
+            </a:r>
+            <a:endParaRPr lang="de-DE" sz="1700" dirty="0"/>
+          </a:p>
+          <a:p>
+            <a:pPr algn="l" indent="0" marL="0">
+              <a:lnSpc>
+                <a:spcPct val="115000"/>
+              </a:lnSpc>
+              <a:spcAft>
+                <a:spcPts val="800"/>
+              </a:spcAft>
+              <a:buNone/>
+            </a:pPr>
+            <a:r>
+              <a:rPr lang="de-DE" sz="1200" dirty="0">
+                <a:solidFill>
+                  <a:srgbClr val="5D626B"/>
+                </a:solidFill>
+                <a:latin typeface="Inter" pitchFamily="34" charset="0"/>
+                <a:ea typeface="Inter" pitchFamily="34" charset="-122"/>
+                <a:cs typeface="Inter" pitchFamily="34" charset="-120"/>
+              </a:rPr>
+              <a:t>Steuert den Browser gegen die deployte App</a:t>
+            </a:r>
+            <a:endParaRPr lang="de-DE" sz="1200" dirty="0"/>
+          </a:p>
+          <a:p>
+            <a:pPr algn="l" indent="0" marL="0">
+              <a:lnSpc>
+                <a:spcPct val="115000"/>
+              </a:lnSpc>
+              <a:buNone/>
+            </a:pPr>
+            <a:r>
+              <a:rPr lang="de-DE" sz="1100" b="1" dirty="0">
+                <a:solidFill>
+                  <a:srgbClr val="B8461A"/>
+                </a:solidFill>
+                <a:latin typeface="Inter" pitchFamily="34" charset="0"/>
+                <a:ea typeface="Inter" pitchFamily="34" charset="-122"/>
+                <a:cs typeface="Inter" pitchFamily="34" charset="-120"/>
+              </a:rPr>
+              <a:t>End-to-End</a:t>
+            </a:r>
+            <a:endParaRPr lang="de-DE" sz="1100" dirty="0"/>
+          </a:p>
+        </p:txBody>
+      </p:sp>
+      <p:sp>
+        <p:nvSpPr>
+          <p:cNvPr id="137" name="Tool 137"/>
+          <p:cNvSpPr/>
+          <p:nvPr/>
+        </p:nvSpPr>
+        <p:spPr>
+          <a:xfrm>
+            <a:off x="8908771" y="2103120"/>
+            <a:ext cx="2470023" cy="1508760"/>
+          </a:xfrm>
+          <a:prstGeom prst="roundRect">
+            <a:avLst>
+              <a:gd name="adj" fmla="val 6000"/>
+            </a:avLst>
+          </a:prstGeom>
+          <a:solidFill>
+            <a:srgbClr val="FDFCF9"/>
+          </a:solidFill>
+          <a:ln w="12700">
+            <a:solidFill>
+              <a:srgbClr val="E2DED4"/>
+            </a:solidFill>
+          </a:ln>
+        </p:spPr>
+        <p:txBody>
+          <a:bodyPr wrap="square" lIns="182880" tIns="182880" rIns="182880" bIns="182880" rtlCol="0" anchor="t">
+            <a:noAutofit/>
+          </a:bodyPr>
+          <a:lstStyle/>
+          <a:p>
+            <a:pPr algn="l" indent="0" marL="0">
+              <a:lnSpc>
+                <a:spcPct val="115000"/>
+              </a:lnSpc>
+              <a:spcAft>
+                <a:spcPts val="600"/>
+              </a:spcAft>
+              <a:buNone/>
+            </a:pPr>
+            <a:r>
+              <a:rPr lang="de-DE" sz="1700" b="1" dirty="0">
+                <a:solidFill>
+                  <a:srgbClr val="1B1E24"/>
+                </a:solidFill>
+                <a:latin typeface="Inter" pitchFamily="34" charset="0"/>
+                <a:ea typeface="Inter" pitchFamily="34" charset="-122"/>
+                <a:cs typeface="Inter" pitchFamily="34" charset="-120"/>
+              </a:rPr>
+              <a:t>MSW</a:t>
+            </a:r>
+            <a:endParaRPr lang="de-DE" sz="1700" dirty="0"/>
+          </a:p>
+          <a:p>
+            <a:pPr algn="l" indent="0" marL="0">
+              <a:lnSpc>
+                <a:spcPct val="115000"/>
+              </a:lnSpc>
+              <a:spcAft>
+                <a:spcPts val="800"/>
+              </a:spcAft>
+              <a:buNone/>
+            </a:pPr>
+            <a:r>
+              <a:rPr lang="de-DE" sz="1200" dirty="0">
+                <a:solidFill>
+                  <a:srgbClr val="5D626B"/>
+                </a:solidFill>
+                <a:latin typeface="Inter" pitchFamily="34" charset="0"/>
+                <a:ea typeface="Inter" pitchFamily="34" charset="-122"/>
+                <a:cs typeface="Inter" pitchFamily="34" charset="-120"/>
+              </a:rPr>
+              <a:t>Fängt HTTP im Service Worker ab: die Netzwerkgrenze</a:t>
+            </a:r>
+            <a:endParaRPr lang="de-DE" sz="1200" dirty="0"/>
+          </a:p>
+          <a:p>
+            <a:pPr algn="l" indent="0" marL="0">
+              <a:lnSpc>
+                <a:spcPct val="115000"/>
+              </a:lnSpc>
+              <a:buNone/>
+            </a:pPr>
+            <a:r>
+              <a:rPr lang="de-DE" sz="1100" b="1" dirty="0">
+                <a:solidFill>
+                  <a:srgbClr val="B8461A"/>
+                </a:solidFill>
+                <a:latin typeface="Inter" pitchFamily="34" charset="0"/>
+                <a:ea typeface="Inter" pitchFamily="34" charset="-122"/>
+                <a:cs typeface="Inter" pitchFamily="34" charset="-120"/>
+              </a:rPr>
+              <a:t>Integration · Component · lokal</a:t>
+            </a:r>
+            <a:endParaRPr lang="de-DE" sz="1100" dirty="0"/>
+          </a:p>
+        </p:txBody>
+      </p:sp>
+      <p:sp>
+        <p:nvSpPr>
+          <p:cNvPr id="138" name="Tool 138"/>
+          <p:cNvSpPr/>
+          <p:nvPr/>
+        </p:nvSpPr>
+        <p:spPr>
+          <a:xfrm>
+            <a:off x="812902" y="3840480"/>
+            <a:ext cx="2470023" cy="1508760"/>
+          </a:xfrm>
+          <a:prstGeom prst="roundRect">
+            <a:avLst>
+              <a:gd name="adj" fmla="val 6000"/>
+            </a:avLst>
+          </a:prstGeom>
+          <a:solidFill>
+            <a:srgbClr val="FDFCF9"/>
+          </a:solidFill>
+          <a:ln w="12700">
+            <a:solidFill>
+              <a:srgbClr val="E2DED4"/>
+            </a:solidFill>
+          </a:ln>
+        </p:spPr>
+        <p:txBody>
+          <a:bodyPr wrap="square" lIns="182880" tIns="182880" rIns="182880" bIns="182880" rtlCol="0" anchor="t">
+            <a:noAutofit/>
+          </a:bodyPr>
+          <a:lstStyle/>
+          <a:p>
+            <a:pPr algn="l" indent="0" marL="0">
+              <a:lnSpc>
+                <a:spcPct val="115000"/>
+              </a:lnSpc>
+              <a:spcAft>
+                <a:spcPts val="600"/>
+              </a:spcAft>
+              <a:buNone/>
+            </a:pPr>
+            <a:r>
+              <a:rPr lang="de-DE" sz="1700" b="1" dirty="0">
+                <a:solidFill>
+                  <a:srgbClr val="1B1E24"/>
+                </a:solidFill>
+                <a:latin typeface="Inter" pitchFamily="34" charset="0"/>
+                <a:ea typeface="Inter" pitchFamily="34" charset="-122"/>
+                <a:cs typeface="Inter" pitchFamily="34" charset="-120"/>
+              </a:rPr>
+              <a:t>OpenAPI-Codegen</a:t>
+            </a:r>
+            <a:endParaRPr lang="de-DE" sz="1700" dirty="0"/>
+          </a:p>
+          <a:p>
+            <a:pPr algn="l" indent="0" marL="0">
+              <a:lnSpc>
+                <a:spcPct val="115000"/>
+              </a:lnSpc>
+              <a:spcAft>
+                <a:spcPts val="800"/>
+              </a:spcAft>
+              <a:buNone/>
+            </a:pPr>
+            <a:r>
+              <a:rPr lang="de-DE" sz="1200" dirty="0">
+                <a:solidFill>
+                  <a:srgbClr val="5D626B"/>
+                </a:solidFill>
+                <a:latin typeface="Inter" pitchFamily="34" charset="0"/>
+                <a:ea typeface="Inter" pitchFamily="34" charset="-122"/>
+                <a:cs typeface="Inter" pitchFamily="34" charset="-120"/>
+              </a:rPr>
+              <a:t>Client, Typen und MSW-Handler aus der Spec</a:t>
+            </a:r>
+            <a:endParaRPr lang="de-DE" sz="1200" dirty="0"/>
+          </a:p>
+          <a:p>
+            <a:pPr algn="l" indent="0" marL="0">
+              <a:lnSpc>
+                <a:spcPct val="115000"/>
+              </a:lnSpc>
+              <a:buNone/>
+            </a:pPr>
+            <a:r>
+              <a:rPr lang="de-DE" sz="1100" b="1" dirty="0">
+                <a:solidFill>
+                  <a:srgbClr val="B8461A"/>
+                </a:solidFill>
+                <a:latin typeface="Inter" pitchFamily="34" charset="0"/>
+                <a:ea typeface="Inter" pitchFamily="34" charset="-122"/>
+                <a:cs typeface="Inter" pitchFamily="34" charset="-120"/>
+              </a:rPr>
+              <a:t>Vertrag</a:t>
+            </a:r>
+            <a:endParaRPr lang="de-DE" sz="1100" dirty="0"/>
+          </a:p>
+        </p:txBody>
+      </p:sp>
+      <p:sp>
+        <p:nvSpPr>
+          <p:cNvPr id="139" name="Tool 139"/>
+          <p:cNvSpPr/>
+          <p:nvPr/>
+        </p:nvSpPr>
+        <p:spPr>
+          <a:xfrm>
+            <a:off x="3511525" y="3840480"/>
+            <a:ext cx="2470023" cy="1508760"/>
+          </a:xfrm>
+          <a:prstGeom prst="roundRect">
+            <a:avLst>
+              <a:gd name="adj" fmla="val 6000"/>
+            </a:avLst>
+          </a:prstGeom>
+          <a:solidFill>
+            <a:srgbClr val="FDFCF9"/>
+          </a:solidFill>
+          <a:ln w="12700">
+            <a:solidFill>
+              <a:srgbClr val="E2DED4"/>
+            </a:solidFill>
+          </a:ln>
+        </p:spPr>
+        <p:txBody>
+          <a:bodyPr wrap="square" lIns="182880" tIns="182880" rIns="182880" bIns="182880" rtlCol="0" anchor="t">
+            <a:noAutofit/>
+          </a:bodyPr>
+          <a:lstStyle/>
+          <a:p>
+            <a:pPr algn="l" indent="0" marL="0">
+              <a:lnSpc>
+                <a:spcPct val="115000"/>
+              </a:lnSpc>
+              <a:spcAft>
+                <a:spcPts val="600"/>
+              </a:spcAft>
+              <a:buNone/>
+            </a:pPr>
+            <a:r>
+              <a:rPr lang="de-DE" sz="1700" b="1" dirty="0">
+                <a:solidFill>
+                  <a:srgbClr val="1B1E24"/>
+                </a:solidFill>
+                <a:latin typeface="Inter" pitchFamily="34" charset="0"/>
+                <a:ea typeface="Inter" pitchFamily="34" charset="-122"/>
+                <a:cs typeface="Inter" pitchFamily="34" charset="-120"/>
+              </a:rPr>
+              <a:t>Faker</a:t>
+            </a:r>
+            <a:endParaRPr lang="de-DE" sz="1700" dirty="0"/>
+          </a:p>
+          <a:p>
+            <a:pPr algn="l" indent="0" marL="0">
+              <a:lnSpc>
+                <a:spcPct val="115000"/>
+              </a:lnSpc>
+              <a:spcAft>
+                <a:spcPts val="800"/>
+              </a:spcAft>
+              <a:buNone/>
+            </a:pPr>
+            <a:r>
+              <a:rPr lang="de-DE" sz="1200" dirty="0">
+                <a:solidFill>
+                  <a:srgbClr val="5D626B"/>
+                </a:solidFill>
+                <a:latin typeface="Inter" pitchFamily="34" charset="0"/>
+                <a:ea typeface="Inter" pitchFamily="34" charset="-122"/>
+                <a:cs typeface="Inter" pitchFamily="34" charset="-120"/>
+              </a:rPr>
+              <a:t>Stabile, geseedete Beispieldaten in den Mocks</a:t>
+            </a:r>
+            <a:endParaRPr lang="de-DE" sz="1200" dirty="0"/>
+          </a:p>
+          <a:p>
+            <a:pPr algn="l" indent="0" marL="0">
+              <a:lnSpc>
+                <a:spcPct val="115000"/>
+              </a:lnSpc>
+              <a:buNone/>
+            </a:pPr>
+            <a:r>
+              <a:rPr lang="de-DE" sz="1100" b="1" dirty="0">
+                <a:solidFill>
+                  <a:srgbClr val="B8461A"/>
+                </a:solidFill>
+                <a:latin typeface="Inter" pitchFamily="34" charset="0"/>
+                <a:ea typeface="Inter" pitchFamily="34" charset="-122"/>
+                <a:cs typeface="Inter" pitchFamily="34" charset="-120"/>
+              </a:rPr>
+              <a:t>Testdaten</a:t>
+            </a:r>
+            <a:endParaRPr lang="de-DE" sz="1100" dirty="0"/>
+          </a:p>
+        </p:txBody>
+      </p:sp>
+      <p:sp>
+        <p:nvSpPr>
+          <p:cNvPr id="140" name="Tool 140"/>
+          <p:cNvSpPr/>
+          <p:nvPr/>
+        </p:nvSpPr>
+        <p:spPr>
+          <a:xfrm>
+            <a:off x="6210148" y="3840480"/>
+            <a:ext cx="2470023" cy="1508760"/>
+          </a:xfrm>
+          <a:prstGeom prst="roundRect">
+            <a:avLst>
+              <a:gd name="adj" fmla="val 6000"/>
+            </a:avLst>
+          </a:prstGeom>
+          <a:solidFill>
+            <a:srgbClr val="FDFCF9"/>
+          </a:solidFill>
+          <a:ln w="12700">
+            <a:solidFill>
+              <a:srgbClr val="E2DED4"/>
+            </a:solidFill>
+          </a:ln>
+        </p:spPr>
+        <p:txBody>
+          <a:bodyPr wrap="square" lIns="182880" tIns="182880" rIns="182880" bIns="182880" rtlCol="0" anchor="t">
+            <a:noAutofit/>
+          </a:bodyPr>
+          <a:lstStyle/>
+          <a:p>
+            <a:pPr algn="l" indent="0" marL="0">
+              <a:lnSpc>
+                <a:spcPct val="115000"/>
+              </a:lnSpc>
+              <a:spcAft>
+                <a:spcPts val="600"/>
+              </a:spcAft>
+              <a:buNone/>
+            </a:pPr>
+            <a:r>
+              <a:rPr lang="de-DE" sz="1700" b="1" dirty="0">
+                <a:solidFill>
+                  <a:srgbClr val="1B1E24"/>
+                </a:solidFill>
+                <a:latin typeface="Inter" pitchFamily="34" charset="0"/>
+                <a:ea typeface="Inter" pitchFamily="34" charset="-122"/>
+                <a:cs typeface="Inter" pitchFamily="34" charset="-120"/>
+              </a:rPr>
+              <a:t>Nx</a:t>
+            </a:r>
+            <a:endParaRPr lang="de-DE" sz="1700" dirty="0"/>
+          </a:p>
+          <a:p>
+            <a:pPr algn="l" indent="0" marL="0">
+              <a:lnSpc>
+                <a:spcPct val="115000"/>
+              </a:lnSpc>
+              <a:spcAft>
+                <a:spcPts val="800"/>
+              </a:spcAft>
+              <a:buNone/>
+            </a:pPr>
+            <a:r>
+              <a:rPr lang="de-DE" sz="1200" dirty="0">
+                <a:solidFill>
+                  <a:srgbClr val="5D626B"/>
+                </a:solidFill>
+                <a:latin typeface="Inter" pitchFamily="34" charset="0"/>
+                <a:ea typeface="Inter" pitchFamily="34" charset="-122"/>
+                <a:cs typeface="Inter" pitchFamily="34" charset="-120"/>
+              </a:rPr>
+              <a:t>Codegen-Targets, affected-Runs, Cache</a:t>
+            </a:r>
+            <a:endParaRPr lang="de-DE" sz="1200" dirty="0"/>
+          </a:p>
+          <a:p>
+            <a:pPr algn="l" indent="0" marL="0">
+              <a:lnSpc>
+                <a:spcPct val="115000"/>
+              </a:lnSpc>
+              <a:buNone/>
+            </a:pPr>
+            <a:r>
+              <a:rPr lang="de-DE" sz="1100" b="1" dirty="0">
+                <a:solidFill>
+                  <a:srgbClr val="B8461A"/>
+                </a:solidFill>
+                <a:latin typeface="Inter" pitchFamily="34" charset="0"/>
+                <a:ea typeface="Inter" pitchFamily="34" charset="-122"/>
+                <a:cs typeface="Inter" pitchFamily="34" charset="-120"/>
+              </a:rPr>
+              <a:t>Pipeline</a:t>
+            </a:r>
+            <a:endParaRPr lang="de-DE" sz="1100" dirty="0"/>
+          </a:p>
+        </p:txBody>
+      </p:sp>
+      <p:sp>
+        <p:nvSpPr>
+          <p:cNvPr id="141" name="Tool 141"/>
+          <p:cNvSpPr/>
+          <p:nvPr/>
+        </p:nvSpPr>
+        <p:spPr>
+          <a:xfrm>
+            <a:off x="8908771" y="3840480"/>
+            <a:ext cx="2470023" cy="1508760"/>
+          </a:xfrm>
+          <a:prstGeom prst="roundRect">
+            <a:avLst>
+              <a:gd name="adj" fmla="val 6000"/>
+            </a:avLst>
+          </a:prstGeom>
+          <a:solidFill>
+            <a:srgbClr val="FDFCF9"/>
+          </a:solidFill>
+          <a:ln w="12700">
+            <a:solidFill>
+              <a:srgbClr val="E2DED4"/>
+            </a:solidFill>
+          </a:ln>
+        </p:spPr>
+        <p:txBody>
+          <a:bodyPr wrap="square" lIns="182880" tIns="182880" rIns="182880" bIns="182880" rtlCol="0" anchor="t">
+            <a:noAutofit/>
+          </a:bodyPr>
+          <a:lstStyle/>
+          <a:p>
+            <a:pPr algn="l" indent="0" marL="0">
+              <a:lnSpc>
+                <a:spcPct val="115000"/>
+              </a:lnSpc>
+              <a:spcAft>
+                <a:spcPts val="600"/>
+              </a:spcAft>
+              <a:buNone/>
+            </a:pPr>
+            <a:r>
+              <a:rPr lang="de-DE" sz="1700" b="1" dirty="0">
+                <a:solidFill>
+                  <a:srgbClr val="1B1E24"/>
+                </a:solidFill>
+                <a:latin typeface="Inter" pitchFamily="34" charset="0"/>
+                <a:ea typeface="Inter" pitchFamily="34" charset="-122"/>
+                <a:cs typeface="Inter" pitchFamily="34" charset="-120"/>
+              </a:rPr>
+              <a:t>Coverage v8</a:t>
+            </a:r>
+            <a:endParaRPr lang="de-DE" sz="1700" dirty="0"/>
+          </a:p>
+          <a:p>
+            <a:pPr algn="l" indent="0" marL="0">
+              <a:lnSpc>
+                <a:spcPct val="115000"/>
+              </a:lnSpc>
+              <a:spcAft>
+                <a:spcPts val="800"/>
+              </a:spcAft>
+              <a:buNone/>
+            </a:pPr>
+            <a:r>
+              <a:rPr lang="de-DE" sz="1200" dirty="0">
+                <a:solidFill>
+                  <a:srgbClr val="5D626B"/>
+                </a:solidFill>
+                <a:latin typeface="Inter" pitchFamily="34" charset="0"/>
+                <a:ea typeface="Inter" pitchFamily="34" charset="-122"/>
+                <a:cs typeface="Inter" pitchFamily="34" charset="-120"/>
+              </a:rPr>
+              <a:t>Abdeckung sichtbar machen, kein Gate</a:t>
+            </a:r>
+            <a:endParaRPr lang="de-DE" sz="1200" dirty="0"/>
+          </a:p>
+          <a:p>
+            <a:pPr algn="l" indent="0" marL="0">
+              <a:lnSpc>
+                <a:spcPct val="115000"/>
+              </a:lnSpc>
+              <a:buNone/>
+            </a:pPr>
+            <a:r>
+              <a:rPr lang="de-DE" sz="1100" b="1" dirty="0">
+                <a:solidFill>
+                  <a:srgbClr val="B8461A"/>
+                </a:solidFill>
+                <a:latin typeface="Inter" pitchFamily="34" charset="0"/>
+                <a:ea typeface="Inter" pitchFamily="34" charset="-122"/>
+                <a:cs typeface="Inter" pitchFamily="34" charset="-120"/>
+              </a:rPr>
+              <a:t>Pipeline</a:t>
+            </a:r>
+            <a:endParaRPr lang="de-DE" sz="1100" dirty="0"/>
+          </a:p>
+        </p:txBody>
+      </p:sp>
+      <p:sp>
+        <p:nvSpPr>
+          <p:cNvPr id="13" name="Text 11"/>
+          <p:cNvSpPr/>
+          <p:nvPr/>
+        </p:nvSpPr>
+        <p:spPr>
+          <a:xfrm>
+            <a:off x="812800" y="6238280"/>
+            <a:ext cx="2876389" cy="238720"/>
+          </a:xfrm>
+          <a:prstGeom prst="rect">
+            <a:avLst/>
+          </a:prstGeom>
+          <a:noFill/>
+          <a:ln/>
+        </p:spPr>
+        <p:txBody>
+          <a:bodyPr wrap="square" lIns="0" tIns="0" rIns="0" bIns="0" rtlCol="0" anchor="t">
+            <a:normAutofit/>
+          </a:bodyPr>
+          <a:lstStyle/>
+          <a:p>
+            <a:pPr algn="l" indent="0" marL="0">
+              <a:lnSpc>
+                <a:spcPts val="1680"/>
+              </a:lnSpc>
+              <a:buNone/>
+            </a:pPr>
+            <a:r>
+              <a:rPr lang="en-US" sz="1200" dirty="0">
+                <a:solidFill>
+                  <a:srgbClr val="5D626B"/>
+                </a:solidFill>
+                <a:latin typeface="Inter" pitchFamily="34" charset="0"/>
+                <a:ea typeface="Inter" pitchFamily="34" charset="-122"/>
+                <a:cs typeface="Inter" pitchFamily="34" charset="-120"/>
+              </a:rPr>
+              <a:t>Frontend-Testing-Strategie für Angular</a:t>
+            </a:r>
+            <a:endParaRPr lang="en-US" sz="1200" dirty="0"/>
+          </a:p>
+        </p:txBody>
+      </p:sp>
+      <p:sp>
+        <p:nvSpPr>
+          <p:cNvPr id="14" name="Text 12"/>
+          <p:cNvSpPr/>
+          <p:nvPr/>
+        </p:nvSpPr>
+        <p:spPr>
+          <a:xfrm>
+            <a:off x="11188502" y="6238280"/>
+            <a:ext cx="241498" cy="238720"/>
+          </a:xfrm>
+          <a:prstGeom prst="rect">
+            <a:avLst/>
+          </a:prstGeom>
+          <a:noFill/>
+          <a:ln/>
+        </p:spPr>
+        <p:txBody>
+          <a:bodyPr wrap="square" lIns="0" tIns="0" rIns="0" bIns="0" rtlCol="0" anchor="t">
+            <a:normAutofit/>
+          </a:bodyPr>
+          <a:lstStyle/>
+          <a:p>
+            <a:pPr algn="l" indent="0" marL="0">
+              <a:lnSpc>
+                <a:spcPts val="1680"/>
+              </a:lnSpc>
+              <a:buNone/>
+            </a:pPr>
+            <a:r>
+              <a:rPr lang="en-US" sz="1200" dirty="0">
+                <a:solidFill>
+                  <a:srgbClr val="5D626B"/>
+                </a:solidFill>
+                <a:latin typeface="Inter" pitchFamily="34" charset="0"/>
+                <a:ea typeface="Inter" pitchFamily="34" charset="-122"/>
+                <a:cs typeface="Inter" pitchFamily="34" charset="-120"/>
+              </a:rPr>
+              <a:t>10</a:t>
             </a:r>
             <a:endParaRPr lang="en-US" sz="1200" dirty="0"/>
           </a:p>
@@ -5134,7 +7910,7 @@
                 <a:ea typeface="Inter" pitchFamily="34" charset="-122"/>
                 <a:cs typeface="Inter" pitchFamily="34" charset="-120"/>
               </a:rPr>
-              <a:t>04</a:t>
+              <a:t>05</a:t>
             </a:r>
             <a:endParaRPr lang="en-US" sz="1200" dirty="0"/>
           </a:p>
@@ -5765,7 +8541,7 @@
                 <a:ea typeface="Inter" pitchFamily="34" charset="-122"/>
                 <a:cs typeface="Inter" pitchFamily="34" charset="-120"/>
               </a:rPr>
-              <a:t>05</a:t>
+              <a:t>06</a:t>
             </a:r>
             <a:endParaRPr lang="en-US" sz="1200" dirty="0"/>
           </a:p>
@@ -6347,7 +9123,7 @@
                 <a:ea typeface="Inter" pitchFamily="34" charset="-122"/>
                 <a:cs typeface="Inter" pitchFamily="34" charset="-120"/>
               </a:rPr>
-              <a:t>06</a:t>
+              <a:t>07</a:t>
             </a:r>
             <a:endParaRPr lang="en-US" sz="1200" dirty="0"/>
           </a:p>
@@ -6534,7 +9310,7 @@
                 <a:ea typeface="Inter" pitchFamily="34" charset="-122"/>
                 <a:cs typeface="Inter" pitchFamily="34" charset="-120"/>
               </a:rPr>
-              <a:t>07</a:t>
+              <a:t>08</a:t>
             </a:r>
             <a:endParaRPr lang="en-US" sz="1200" dirty="0"/>
           </a:p>
@@ -8156,7 +10932,7 @@
                 <a:ea typeface="Inter" pitchFamily="34" charset="-122"/>
                 <a:cs typeface="Inter" pitchFamily="34" charset="-120"/>
               </a:rPr>
-              <a:t>08</a:t>
+              <a:t>09</a:t>
             </a:r>
             <a:endParaRPr lang="en-US" sz="1200" dirty="0"/>
           </a:p>
@@ -8873,7 +11649,7 @@
                 <a:ea typeface="Inter" pitchFamily="34" charset="-122"/>
                 <a:cs typeface="Inter" pitchFamily="34" charset="-120"/>
               </a:rPr>
-              <a:t>09</a:t>
+              <a:t>11</a:t>
             </a:r>
             <a:endParaRPr lang="en-US" sz="1200" dirty="0"/>
           </a:p>

</xml_diff>

<commit_message>
refactor: generierte dtos statt eigener modelle, keine mapper
- data-access gibt dtos unverändert zurück, state/ui/utils/testing nutzen sie direkt
- types nur noch frontend-eigene typen (CheckSummary, DeskSummary)
- datei-kinds dto/mapper + eslint-ausnahme *.dto.ts raus, internal/-beispiel next-checkin-id
- doku + decks: dto-entscheidung, slice = vertical (geschlossenes feature)

Co-Authored-By: Claude Opus 5.5 (1M context) <noreply@anthropic.com>
Claude-Session: https://claude.ai/code/session_01PRenLBL8AH6oon1wSdsdLf
</commit_message>
<xml_diff>
--- a/docs/Frontend-Testing-Strategie für Angular.pptx
+++ b/docs/Frontend-Testing-Strategie für Angular.pptx
@@ -4318,7 +4318,7 @@
                 <a:ea typeface="Inter" pitchFamily="34" charset="-122"/>
                 <a:cs typeface="Inter" pitchFamily="34" charset="-120"/>
               </a:rPr>
-              <a:t>Utils, Pipes, Mapper</a:t>
+              <a:t>Utils, Pipes, Validatoren</a:t>
             </a:r>
             <a:endParaRPr lang="de-DE" sz="1100" dirty="0"/>
           </a:p>
@@ -8847,7 +8847,7 @@
                 <a:ea typeface="Inter" pitchFamily="34" charset="-122"/>
                 <a:cs typeface="Inter" pitchFamily="34" charset="-120"/>
               </a:rPr>
-              <a:t>Reine Logik: Utils, Pipes, Validatoren, Mapper. Läuft in Vitest.</a:t>
+              <a:t>Reine Logik: Utils, Pipes, Validatoren. Läuft in Vitest.</a:t>
             </a:r>
             <a:endParaRPr lang="en-US" sz="1400" dirty="0"/>
           </a:p>

</xml_diff>